<commit_message>
Quarter dividers rebased to the biweekly walk
The deck-ending Quarter 2/3/4 dividers (S6, S11, S17) now speak the
current-condition calendar: Sessions 7-8/9-10/11, 12-17 (14 absorbed),
and 18-22 (19 at the lab), every other Tuesday - replacing the school
clock's week ranges and Wednesday counts.

Co-Authored-By: Claude Fable 5 <noreply@anthropic.com>
</commit_message>
<xml_diff>
--- a/_implementation-notes/evening-series/FotH Evening Session 11 Slides DRAFT v1.pptx
+++ b/_implementation-notes/evening-series/FotH Evening Session 11 Slides DRAFT v1.pptx
@@ -1459,13 +1459,11 @@
           <a:lstStyle/>
           <a:p>
             <a:r>
-              <a:rPr lang="en-US" sz="1200"/>
               <a:t>QUARTER 3 · pre-session · DIVIDER</a:t>
             </a:r>
           </a:p>
           <a:p>
             <a:r>
-              <a:rPr lang="en-US" sz="1200"/>
               <a:t>On screen as families arrive — first evenings back after the Christmas break. Today is The Return: the open runs slow on purpose. Greet warmly at the door; nobody owes an explanation for the break.</a:t>
             </a:r>
           </a:p>
@@ -7042,7 +7040,7 @@
                 </a:solidFill>
                 <a:latin typeface="Calibri"/>
               </a:rPr>
-              <a:t>Weeks 12–17  ·  Six Wednesdays · The Return, Mission, the Rhythm and the Four Questions</a:t>
+              <a:t>Sessions 12 · 13 · 15 · 16 · 17  —  five evenings, every other Tuesday · the Return, Mission, the Rhythm, Family Night, the Float</a:t>
             </a:r>
           </a:p>
         </p:txBody>

</xml_diff>

<commit_message>
v2.33 (John's word, 13 October): Session 11 Any Doubts? checked against the Four Connects deck
New slide and Reading Card: the silent place (remember where God seemed
silent, bring in the time you heard, invite Jesus in with permission, about
three minutes of silence, write - is something blocking? the downside of a
deeper connection? - share optional). The check-in receives the Garden's
preparation sentence; the teaching names two kinds of doubt (the four steps /
the How Did You Know? checks); week two adds "something I heard and did not
obey?" and "what is at risk for me to hear?". Clock re-timed (pairs 26 min,
silent place 13). School calendar stripped (midpoint, quarter break,
Christmas, January). Master renumber: S11 = 159-175, 323 pages; leader notes
rebuilt S11-S22; numbering map updated. Take-home and run sheet filled in.

Co-Authored-By: Claude Opus 5.5 <noreply@anthropic.com>
</commit_message>
<xml_diff>
--- a/_implementation-notes/evening-series/FotH Evening Session 11 Slides DRAFT v1.pptx
+++ b/_implementation-notes/evening-series/FotH Evening Session 11 Slides DRAFT v1.pptx
@@ -18,6 +18,7 @@
     <p:sldId id="422" r:id="rId144"/>
     <p:sldId id="423" r:id="rId145"/>
     <p:sldId id="424" r:id="rId146"/>
+    <p:sldId id="538" r:id="rId23"/>
     <p:sldId id="425" r:id="rId147"/>
     <p:sldId id="426" r:id="rId148"/>
     <p:sldId id="536" r:id="rId25"/>
@@ -840,14 +841,12 @@
           <a:lstStyle/>
           <a:p>
             <a:r>
-              <a:rPr lang="en-US" sz="1200"/>
               <a:t>S11 · 7:00–7:08 · LEAD: CONTAINER HOLDER</a:t>
             </a:r>
           </a:p>
           <a:p>
             <a:r>
-              <a:rPr lang="en-US" sz="1200"/>
-              <a:t>BEATS: 1. Week 11 — last gathering of the quarter and the exact midpoint of the year: eleven evenings behind, eleven ahead. 2. Today: Any Doubts? — bringing the small quiet doubts we never say aloud, honestly, to God, in front of one other person. 3. With the Garden, one of the two highest-confidence practices in this whole body of work — treat it with care. 4. Frame it early and repeat it: doubt is not disbelief; this is the gap between what we say and what we actually trust.</a:t>
+              <a:t>BEATS: 1. Session 11 — the last evening of Connect with God. Tonight picks up the Garden evening's thread: what I'm not sure was God. 2. Today: Any Doubts? — bringing the small quiet doubts we never say aloud, honestly, to God, in front of one other person. 3. With the Garden, one of the two highest-confidence practices in this whole body of work — treat it with care. 4. Frame it early and repeat it: doubt is not disbelief; this is the gap between what we say and what we actually trust. 5. The shape (John's word, 13 October): the four steps in pairs, then the silent place from the Four Connects deck — remember where God seemed silent, bring in the time you heard, invite Jesus in.</a:t>
             </a:r>
           </a:p>
         </p:txBody>
@@ -893,7 +892,7 @@
           <a:lstStyle/>
           <a:p>
             <a:r>
-              <a:t>S11 · 7:00–7:08 · LEAD: CONTAINER HOLDER</a:t>
+              <a:t>S11 · 7:00–7:06 · LEAD: CONTAINER HOLDER</a:t>
             </a:r>
           </a:p>
           <a:p>
@@ -949,20 +948,17 @@
           <a:lstStyle/>
           <a:p>
             <a:r>
-              <a:rPr lang="en-US" sz="1200"/>
-              <a:t>S11 · 7:08–7:25 · LEAD: CONTAINER HOLDER</a:t>
-            </a:r>
-          </a:p>
-          <a:p>
-            <a:r>
-              <a:rPr lang="en-US" sz="1200"/>
-              <a:t>BEATS: 1. One sentence on the garden returns — how it went, what surfaced, or that you didn't get to it. 2. Take 2–3 voluntary contributions; receive without commentary. 3. Move on with: 'Good. The garden is still there. You can return any time. We continue.'</a:t>
-            </a:r>
-          </a:p>
-          <a:p>
-            <a:r>
-              <a:rPr lang="en-US" sz="1200"/>
-              <a:t>CUES: Arranged parent opens (check the Run Card) — never cold-call a teen; pass-anytime holds.</a:t>
+              <a:t>S11 · 7:06–7:14 · LEAD: CONTAINER HOLDER</a:t>
+            </a:r>
+          </a:p>
+          <a:p>
+            <a:r>
+              <a:t>BEATS: 1. One sentence on the garden returns — how it went, what surfaced, whether anyone tested what they noticed with the How Did You Know? card. 2. The preparation sentence from the Garden take-home: 'One thing I'm not sure was God, or one question I'd bring tonight.' Say it aloud, or keep it for your pair — both are fine. 3. Two or three voluntary contributions; receive without commentary. Move on with: 'Good. The garden is still there. Tonight we bring the questions.'</a:t>
+            </a:r>
+          </a:p>
+          <a:p>
+            <a:r>
+              <a:t>CUES: Arranged parent opens — never cold-call a teen; pass-anytime holds.</a:t>
             </a:r>
           </a:p>
         </p:txBody>
@@ -1008,13 +1004,11 @@
           <a:lstStyle/>
           <a:p>
             <a:r>
-              <a:rPr lang="en-US" sz="1200"/>
-              <a:t>S11 · 7:25–7:33 · LEAD: CONTENT PRESENTER</a:t>
-            </a:r>
-          </a:p>
-          <a:p>
-            <a:r>
-              <a:rPr lang="en-US" sz="1200"/>
+              <a:t>S11 · 7:14–7:20 · LEAD: CONTENT PRESENTER</a:t>
+            </a:r>
+          </a:p>
+          <a:p>
+            <a:r>
               <a:t>BEATS: 1. Read Mark 9:14–29 IN FULL from the physical Bible, slowly, without stopping to comment — the verse lands differently inside the whole scene. 2. Teach the model: the father names belief and unbelief at once — 'I believe; help my unbelief' — and Jesus does not rebuke him; He heals the boy. 3. Most of us say the believing half loud and bury the unbelieving half, where it works as a quiet brake on faith. 4. Today is not generating new doubts — it is bringing the unbelief already there into the open, and bringing it to Jesus.</a:t>
             </a:r>
           </a:p>
@@ -1061,25 +1055,21 @@
           <a:lstStyle/>
           <a:p>
             <a:r>
-              <a:rPr lang="en-US" sz="1200"/>
-              <a:t>S11 · 7:33–7:41 · LEAD: CONTENT PRESENTER</a:t>
-            </a:r>
-          </a:p>
-          <a:p>
-            <a:r>
-              <a:rPr lang="en-US" sz="1200"/>
-              <a:t>BEATS: 1. Callback, 30s: journals open to the first-night question — naming a doubt takes the same courage. 2. The seat for the skeptic, named ALOUD: a doubt bigger than today's list is welcome and has its own standing door — any Companion, any week, for as long as it takes. 3. Whiteboard walk: NAME (specific, not abstract) / EXAGGERATE (expose the brake, not endorse it) / SIT (feel it, 10–15s) / RE-READ (the Spirit works; you notice). 4. Demo with a Co-Companion, 3 min — real scripture, real small doubt; do NOT resolve it at the end. The pairs calibrate everything against this demo.</a:t>
-            </a:r>
-          </a:p>
-          <a:p>
-            <a:r>
-              <a:rPr lang="en-US" sz="1200"/>
+              <a:t>S11 · 7:20–7:28 · LEAD: CONTENT PRESENTER</a:t>
+            </a:r>
+          </a:p>
+          <a:p>
+            <a:r>
+              <a:t>BEATS: 1. Callback, 30s: journals open to the first-night question — naming a doubt takes the same courage. 2. The seat for the skeptic, named ALOUD: a doubt bigger than today's list is welcome and has its own standing door — any Companion, any week, for as long as it takes. 3. Name the two kinds of doubt: doubting what God has said — tonight's four steps; and doubting whether I heard him at all — that goes to the How Did You Know? checks from the Garden evening, tested in company, never settled alone. 4. Whiteboard walk: NAME (specific, not abstract) / EXAGGERATE (expose the brake, not endorse it) / SIT (feel it, 10–15s) / RE-READ (the Spirit works; you notice). 5. Demo with a Co-Companion, 3 min — real scripture, real small doubt; do NOT resolve it at the end. The pairs calibrate everything against this demo.</a:t>
+            </a:r>
+          </a:p>
+          <a:p>
+            <a:r>
               <a:t>CUES: Keep the demo brief — do not let teaching eat the pair time.</a:t>
             </a:r>
           </a:p>
           <a:p>
             <a:r>
-              <a:rPr lang="en-US" sz="1200"/>
               <a:t>SUB: Demo YOUR OWN real, small doubt — never fake one, never borrow the founder's. If you cannot bring one honestly, walk the four steps only and let the arranged parents' first turns carry the modeling.</a:t>
             </a:r>
           </a:p>
@@ -1126,7 +1116,7 @@
           <a:lstStyle/>
           <a:p>
             <a:r>
-              <a:t>S11 · 7:41–7:43 · LEAD: CONTENT PRESENTER · TRANSITION</a:t>
+              <a:t>S11 · 7:28–7:30 · LEAD: CONTENT PRESENTER · TRANSITION</a:t>
             </a:r>
           </a:p>
           <a:p>
@@ -1182,19 +1172,16 @@
           <a:lstStyle/>
           <a:p>
             <a:r>
-              <a:rPr lang="en-US" sz="1200"/>
-              <a:t>S11 · 7:43–8:14 · LEAD: CONTENT PRESENTER · PAIRS</a:t>
-            </a:r>
-          </a:p>
-          <a:p>
-            <a:r>
-              <a:rPr lang="en-US" sz="1200"/>
-              <a:t>BEATS: 1. Thirty minutes: one full cycle each direction, about 7 min per turn, parent's turn first; partial second cycle if time allows. Companion calls switches at seven minutes; never interrupt a re-read. 2. The turn: partner reads; 'the doubt I am holding is ___'; gentle exaggerate; sit 10–20s; re-read; 'what I notice this time is ___'. 3. Interventions: apologetics — 'we're not arguing the doubt'; no doubt found — honest, run the partner's cycle; exaggeration won't come — don't push; distress — stop the exaggeration, re-read, sit with them.</a:t>
-            </a:r>
-          </a:p>
-          <a:p>
-            <a:r>
-              <a:rPr lang="en-US" sz="1200"/>
+              <a:t>S11 · 7:30–7:56 · LEAD: CONTENT PRESENTER · PAIRS</a:t>
+            </a:r>
+          </a:p>
+          <a:p>
+            <a:r>
+              <a:t>BEATS: 1. Twenty-six minutes: one full cycle each direction, about 12 min per turn, parent's turn first. The silent place follows, so hold the clock. Companion calls switches at seven minutes; never interrupt a re-read. 2. The turn: partner reads; 'the doubt I am holding is ___'; gentle exaggerate; sit 10–20s; re-read; 'what I notice this time is ___'. 3. Interventions: apologetics — 'we're not arguing the doubt'; no doubt found — honest, run the partner's cycle; exaggeration won't come — don't push; distress — stop the exaggeration, re-read, sit with them.</a:t>
+            </a:r>
+          </a:p>
+          <a:p>
+            <a:r>
               <a:t>GUARD: The practice never runs on a scripture the person actively rejects — flicker, not hurricane. A parent's doubt about the very teen across from them moves to a different doubt today and a 1:1 later. Anything bigger than the exercise: bless the naming, end the cycle gently, follow up within 48 hours.</a:t>
             </a:r>
           </a:p>
@@ -1241,19 +1228,16 @@
           <a:lstStyle/>
           <a:p>
             <a:r>
-              <a:rPr lang="en-US" sz="1200"/>
-              <a:t>S11 · 8:14–8:20 · LEAD: CONTAINER HOLDER</a:t>
-            </a:r>
-          </a:p>
-          <a:p>
-            <a:r>
-              <a:rPr lang="en-US" sz="1200"/>
-              <a:t>BEATS: 1. What happened in your pair stays in your pair — not back to the pair, not around the dinner table, unless the one who named it brings it up first. 2. One word about the practice, not the doubt: 'surprising', 'heavy', 'honest', 'lighter'. Receive with a nod; no commentary. 3. Two closers: this practice takes five minutes alone, for the rest of your life; and the naming is ours — the resolution is the Spirit's work.</a:t>
-            </a:r>
-          </a:p>
-          <a:p>
-            <a:r>
-              <a:rPr lang="en-US" sz="1200"/>
+              <a:t>S11 · 8:09–8:15 · LEAD: CONTAINER HOLDER</a:t>
+            </a:r>
+          </a:p>
+          <a:p>
+            <a:r>
+              <a:t>BEATS: 1. What happened in your pair stays in your pair — not back to the pair, not around the dinner table, unless the one who named it brings it up first. 2. One word about the practices, not the doubt or the silent place: 'surprising', 'heavy', 'honest', 'lighter'. Receive with a nod; no commentary. 3. Two closers: this practice takes five minutes alone, for the rest of your life; and the naming is ours — the resolution is the Spirit's work.</a:t>
+            </a:r>
+          </a:p>
+          <a:p>
+            <a:r>
               <a:t>CUES: Pass-anytime holds. Watch faces — follow up offline within 48 hours on anything the night stirred.</a:t>
             </a:r>
           </a:p>
@@ -1300,14 +1284,17 @@
           <a:lstStyle/>
           <a:p>
             <a:r>
-              <a:rPr lang="en-US" sz="1200"/>
-              <a:t>S11 · 8:20–8:24 · LEAD: CONTENT PRESENTER</a:t>
-            </a:r>
-          </a:p>
-          <a:p>
-            <a:r>
-              <a:rPr lang="en-US" sz="1200"/>
-              <a:t>BEATS: 1. Personal Doubts Inventory (H11.2): twenty minutes once this week — list 5–10 scriptures you say you believe, rate your honest trust in each, and write one specific sentence on the 2–3 lowest. No shame, just data; nobody ever sees it. 2. Hand out the Quarterly Pulse (H11.4): three questions, five minutes at home, honest — back in the bin at The Return's door in January. 3. 'Body in the room, mind on the mortgage' is exactly the kind of answer the page is for.</a:t>
+              <a:t>S11 · 8:15–8:21 · LEAD: CONTENT PRESENTER</a:t>
+            </a:r>
+          </a:p>
+          <a:p>
+            <a:r>
+              <a:t>BEATS: 1. Week one, the Personal Doubts Inventory (H11.2): twenty minutes once — list 5–10 scriptures you say you believe, rate your honest trust in each, and write one specific sentence on the two or three lowest. No shame, just data; nobody ever sees it. 2. Week two, two journal questions from the Four Connects deck: 'Is there something I heard and did not obey?' — obedience opens you to hear more — and 'What is at risk for me to hear?' 3. Anything you're not sure was God: the How Did You Know? card, tested in company. 4. Hand out the Quarterly Pulse (H11.4): three questions, five minutes at home, honest — bring it back next evening.</a:t>
+            </a:r>
+          </a:p>
+          <a:p>
+            <a:r>
+              <a:t>FROM: the Four Connects deck (FotH, September 2025), 'Hearing God — What If?'.</a:t>
             </a:r>
           </a:p>
         </p:txBody>
@@ -1353,13 +1340,11 @@
           <a:lstStyle/>
           <a:p>
             <a:r>
-              <a:rPr lang="en-US" sz="1200"/>
-              <a:t>S11 · 8:24–8:28 · LEAD: BOTH LEADERS</a:t>
-            </a:r>
-          </a:p>
-          <a:p>
-            <a:r>
-              <a:rPr lang="en-US" sz="1200"/>
+              <a:t>S11 · 8:21–8:25 · LEAD: BOTH LEADERS</a:t>
+            </a:r>
+          </a:p>
+          <a:p>
+            <a:r>
               <a:t>BEATS: 1. Same round: leader's three answers first, then the room's two questions — two or three voices is plenty. 2. Receive without defending — 'thank you' is the whole response. 3. May be dropped if the room needs quiet; dropping it twice running goes to the team debrief.</a:t>
             </a:r>
           </a:p>
@@ -1406,17 +1391,83 @@
           <a:lstStyle/>
           <a:p>
             <a:r>
-              <a:t>S11 · 8:28–8:30 · LEAD: CONTAINER HOLDER</a:t>
-            </a:r>
-          </a:p>
-          <a:p>
-            <a:r>
-              <a:t>BEATS: 1. What was named in your pair is yours — some doubts quietly resolve, some deepen before they release; both are normal. If anything is heavier than today could hold, reach out. 2. Announce the road: quarter break now; The Return in January; then Week 13 turns outward to Mission, on toward the Rhythm week and the two commissionings. 3. Aaronic blessing. 'Keep one practice alive over the break — just one. See you in January, at The Return. Merry Christmas to every house in this room.'</a:t>
+              <a:t>S11 · 8:25–8:30 · LEAD: CONTAINER HOLDER</a:t>
+            </a:r>
+          </a:p>
+          <a:p>
+            <a:r>
+              <a:t>BEATS: 1. What was named in your pair is yours — some doubts quietly resolve, some deepen before they release; both are normal. If anything is heavier than tonight could hold, reach out. 2. Announce the next evening and its date, as the team has set it; Session 12 turns toward Mission. 3. Aaronic blessing.</a:t>
             </a:r>
           </a:p>
           <a:p>
             <a:r>
               <a:t>BLESSINGS: eyes on the person, not the screen — nothing to read; say what is on your heart for them, specific and short.</a:t>
+            </a:r>
+          </a:p>
+        </p:txBody>
+      </p:sp>
+    </p:spTree>
+  </p:cSld>
+  <p:clrMapOvr>
+    <a:masterClrMapping/>
+  </p:clrMapOvr>
+</p:notes>
+</file>
+
+<file path=ppt/notesSlides/notesSlide15.xml><?xml version="1.0" encoding="utf-8"?>
+<p:notes xmlns:a="http://schemas.openxmlformats.org/drawingml/2006/main" xmlns:p="http://schemas.openxmlformats.org/presentationml/2006/main" xmlns:r="http://schemas.openxmlformats.org/officeDocument/2006/relationships">
+  <p:cSld>
+    <p:spTree>
+      <p:nvGrpSpPr>
+        <p:cNvPr id="1" name=""/>
+        <p:cNvGrpSpPr/>
+        <p:nvPr/>
+      </p:nvGrpSpPr>
+      <p:grpSpPr>
+        <a:xfrm>
+          <a:off x="0" y="0"/>
+          <a:ext cx="0" cy="0"/>
+          <a:chOff x="0" y="0"/>
+          <a:chExt cx="0" cy="0"/>
+        </a:xfrm>
+      </p:grpSpPr>
+      <p:sp>
+        <p:nvSpPr>
+          <p:cNvPr id="2" name="Notes Placeholder 1"/>
+          <p:cNvSpPr>
+            <a:spLocks noGrp="1"/>
+          </p:cNvSpPr>
+          <p:nvPr>
+            <p:ph type="body" idx="1"/>
+          </p:nvPr>
+        </p:nvSpPr>
+        <p:spPr/>
+        <p:txBody>
+          <a:bodyPr/>
+          <a:lstStyle/>
+          <a:p>
+            <a:r>
+              <a:t>S11 · 7:56–8:09 · LEAD: CONTENT PRESENTER</a:t>
+            </a:r>
+          </a:p>
+          <a:p>
+            <a:r>
+              <a:t>BEATS: 1. The reader reads the Silent Place Reading Card. Settle, 1 minute. 2. Remember, about 2 minutes: a time or place where God seemed silent — a dry spell, a prayer that met nothing. Get clear on it. 3. Bring in the anchor: the time you did hear, remembered at the Garden evening — what it looked, sounded and felt like — into the silent place. 4. Invite Jesus into the silent place; give him permission to do or say anything he wishes; then about three minutes of silence. See what he does. Return. 5. Write, 3 minutes: what did he do? Is something blocking, or in the way? What might be the downside of a deeper connection — what would change? 6. Share, 2 minutes, optional: one circle, by invitation; 'Thank you' is the whole response.</a:t>
+            </a:r>
+          </a:p>
+          <a:p>
+            <a:r>
+              <a:t>CUES: Sharing is optional — say so twice. No anchor from the Garden evening? Offer a time creation stopped you, or simply John 10:27.</a:t>
+            </a:r>
+          </a:p>
+          <a:p>
+            <a:r>
+              <a:t>GUARD: Silence is not a verdict on anyone. If a silent place opens something heavy, the Settle Protocol stands — for the person, not the circle; follow up within 48 hours.</a:t>
+            </a:r>
+          </a:p>
+          <a:p>
+            <a:r>
+              <a:t>FROM: the Four Connects deck (FotH, September 2025), 'Hearing God — The How' (remember a place where the Lord was not speaking; change with the anchor; invite in Jesus, give him permission; share optional) and 'Connect with God' (is something blocking; the downside to a deeper connection).</a:t>
             </a:r>
           </a:p>
         </p:txBody>
@@ -1467,7 +1518,7 @@
           </a:p>
           <a:p>
             <a:r>
-              <a:t>On screen as families arrive — first evenings back after the Christmas break. Today is The Return: the open runs slow on purpose. Greet warmly at the door; nobody owes an explanation for the break.</a:t>
+              <a:t>On screen as families arrive at the next evening. Greet warmly at the door.</a:t>
             </a:r>
           </a:p>
         </p:txBody>
@@ -1523,7 +1574,7 @@
           </a:p>
           <a:p>
             <a:r>
-              <a:t>1. Locate tonight on the map, plainly: Session 11 stands in the third box — Connect with God — at the year's midpoint. Each connection makes the next one real (Matt. 22:37–40).</a:t>
+              <a:t>1. Locate tonight on the map, plainly: Session 11 stands in the third box — Connect with God. Each connection makes the next one real (Matt. 22:37–40).</a:t>
             </a:r>
           </a:p>
           <a:p>
@@ -5185,7 +5236,7 @@
 </file>
 
 <file path=ppt/slides/slide11.xml><?xml version="1.0" encoding="utf-8"?>
-<p:sld xmlns:a="http://schemas.openxmlformats.org/drawingml/2006/main" xmlns:r="http://schemas.openxmlformats.org/officeDocument/2006/relationships" xmlns:p="http://schemas.openxmlformats.org/presentationml/2006/main">
+<p:sld xmlns:a="http://schemas.openxmlformats.org/drawingml/2006/main" xmlns:p="http://schemas.openxmlformats.org/presentationml/2006/main" xmlns:r="http://schemas.openxmlformats.org/officeDocument/2006/relationships">
   <p:cSld>
     <p:spTree>
       <p:nvGrpSpPr>
@@ -5193,14 +5244,7 @@
         <p:cNvGrpSpPr/>
         <p:nvPr/>
       </p:nvGrpSpPr>
-      <p:grpSpPr>
-        <a:xfrm>
-          <a:off x="0" y="0"/>
-          <a:ext cx="0" cy="0"/>
-          <a:chOff x="0" y="0"/>
-          <a:chExt cx="0" cy="0"/>
-        </a:xfrm>
-      </p:grpSpPr>
+      <p:grpSpPr/>
       <p:sp>
         <p:nvSpPr>
           <p:cNvPr id="2" name="Rectangle 1"/>
@@ -5264,7 +5308,7 @@
                 </a:solidFill>
                 <a:latin typeface="Cambria"/>
               </a:rPr>
-              <a:t>Merge and Surface</a:t>
+              <a:t>The Silent Place — Bringing In the Time You Heard</a:t>
             </a:r>
           </a:p>
         </p:txBody>
@@ -5289,59 +5333,59 @@
           <a:bodyPr wrap="square" lIns="91440" tIns="91440" rIns="91440" bIns="91440"/>
           <a:lstStyle/>
           <a:p>
-            <a:pPr marL="274320" indent="-274320">
+            <a:pPr marL="342900" indent="-342900">
               <a:spcAft>
-                <a:spcPts val="900"/>
+                <a:spcPts val="750"/>
               </a:spcAft>
             </a:pPr>
             <a:r>
-              <a:rPr sz="2800" b="1" i="0">
+              <a:rPr sz="2000" b="1" i="0">
                 <a:solidFill>
                   <a:srgbClr val="97BC62"/>
                 </a:solidFill>
                 <a:latin typeface="Calibri"/>
               </a:rPr>
-              <a:t>•  </a:t>
-            </a:r>
-            <a:r>
-              <a:rPr sz="2800" b="0" i="0">
+              <a:t>1   </a:t>
+            </a:r>
+            <a:r>
+              <a:rPr sz="2000" b="0" i="0">
                 <a:solidFill>
                   <a:srgbClr val="222B22"/>
                 </a:solidFill>
                 <a:latin typeface="Calibri"/>
               </a:rPr>
-              <a:t>What happened in your pair stays in your pair — no one will be asked to share a doubt or a scripture</a:t>
-            </a:r>
-          </a:p>
-          <a:p>
-            <a:pPr marL="274320" indent="-274320">
+              <a:t>Settle (1 min) — breathe; be present; he is here</a:t>
+            </a:r>
+          </a:p>
+          <a:p>
+            <a:pPr marL="342900" indent="-342900">
               <a:spcAft>
-                <a:spcPts val="900"/>
+                <a:spcPts val="750"/>
               </a:spcAft>
             </a:pPr>
             <a:r>
-              <a:rPr sz="2800" b="1" i="0">
+              <a:rPr sz="2000" b="1" i="0">
                 <a:solidFill>
                   <a:srgbClr val="97BC62"/>
                 </a:solidFill>
                 <a:latin typeface="Calibri"/>
               </a:rPr>
-              <a:t>•  </a:t>
-            </a:r>
-            <a:r>
-              <a:rPr sz="2800" b="0" i="0">
+              <a:t>2   </a:t>
+            </a:r>
+            <a:r>
+              <a:rPr sz="2000" b="0" i="0">
                 <a:solidFill>
                   <a:srgbClr val="222B22"/>
                 </a:solidFill>
                 <a:latin typeface="Calibri"/>
               </a:rPr>
-              <a:t>“One word about what the practice was like. Not the doubt — the practice.”</a:t>
-            </a:r>
-          </a:p>
-          <a:p>
-            <a:pPr marL="685800" indent="-274320">
+              <a:t>Remember (2 min) — a time or place where God seemed silent: a dry spell, a prayer that met nothing. Get clear on it</a:t>
+            </a:r>
+          </a:p>
+          <a:p>
+            <a:pPr marL="342900" indent="-342900">
               <a:spcAft>
-                <a:spcPts val="700"/>
+                <a:spcPts val="750"/>
               </a:spcAft>
             </a:pPr>
             <a:r>
@@ -5351,66 +5395,116 @@
                 </a:solidFill>
                 <a:latin typeface="Calibri"/>
               </a:rPr>
-              <a:t>–  </a:t>
-            </a:r>
-            <a:r>
-              <a:rPr sz="2000" b="0" i="1">
+              <a:t>3   </a:t>
+            </a:r>
+            <a:r>
+              <a:rPr sz="2000" b="0" i="0">
                 <a:solidFill>
                   <a:srgbClr val="222B22"/>
                 </a:solidFill>
                 <a:latin typeface="Calibri"/>
               </a:rPr>
-              <a:t>“Surprising.” “Heavy.” “Quiet.” “Awkward.” “Honest.” “Lighter.” Pass anytime</a:t>
-            </a:r>
-          </a:p>
-          <a:p>
-            <a:pPr marL="274320" indent="-274320">
+              <a:t>Bring in the time you heard — the memory from the Garden evening: what it looked, sounded, felt like</a:t>
+            </a:r>
+          </a:p>
+          <a:p>
+            <a:pPr marL="342900" indent="-342900">
               <a:spcAft>
-                <a:spcPts val="900"/>
+                <a:spcPts val="750"/>
               </a:spcAft>
             </a:pPr>
             <a:r>
-              <a:rPr sz="2800" b="1" i="0">
+              <a:rPr sz="2000" b="1" i="0">
                 <a:solidFill>
                   <a:srgbClr val="97BC62"/>
                 </a:solidFill>
                 <a:latin typeface="Calibri"/>
               </a:rPr>
-              <a:t>•  </a:t>
-            </a:r>
-            <a:r>
-              <a:rPr sz="2800" b="0" i="0">
+              <a:t>4   </a:t>
+            </a:r>
+            <a:r>
+              <a:rPr sz="2000" b="0" i="0">
                 <a:solidFill>
                   <a:srgbClr val="222B22"/>
                 </a:solidFill>
                 <a:latin typeface="Calibri"/>
               </a:rPr>
-              <a:t>This practice fits in five minutes alone, or twenty with a friend — a way of bringing your real questions to God for the rest of your life</a:t>
-            </a:r>
-          </a:p>
-          <a:p>
-            <a:pPr marL="274320" indent="-274320">
+              <a:t>Invite Jesus into the silent place (4 min) — give him permission to do or say anything he wishes; see what he does</a:t>
+            </a:r>
+          </a:p>
+          <a:p>
+            <a:pPr marL="342900" indent="-342900">
               <a:spcAft>
-                <a:spcPts val="900"/>
+                <a:spcPts val="750"/>
               </a:spcAft>
             </a:pPr>
             <a:r>
-              <a:rPr sz="2800" b="1" i="0">
+              <a:rPr sz="2000" b="1" i="0">
                 <a:solidFill>
                   <a:srgbClr val="97BC62"/>
                 </a:solidFill>
                 <a:latin typeface="Calibri"/>
               </a:rPr>
+              <a:t>5   </a:t>
+            </a:r>
+            <a:r>
+              <a:rPr sz="2000" b="0" i="0">
+                <a:solidFill>
+                  <a:srgbClr val="222B22"/>
+                </a:solidFill>
+                <a:latin typeface="Calibri"/>
+              </a:rPr>
+              <a:t>Write (3 min) — what did he do? Is something blocking, or in the way? What might be the downside of a deeper connection?</a:t>
+            </a:r>
+          </a:p>
+          <a:p>
+            <a:pPr marL="342900" indent="-342900">
+              <a:spcAft>
+                <a:spcPts val="750"/>
+              </a:spcAft>
+            </a:pPr>
+            <a:r>
+              <a:rPr sz="2000" b="1" i="0">
+                <a:solidFill>
+                  <a:srgbClr val="97BC62"/>
+                </a:solidFill>
+                <a:latin typeface="Calibri"/>
+              </a:rPr>
+              <a:t>6   </a:t>
+            </a:r>
+            <a:r>
+              <a:rPr sz="2000" b="0" i="0">
+                <a:solidFill>
+                  <a:srgbClr val="222B22"/>
+                </a:solidFill>
+                <a:latin typeface="Calibri"/>
+              </a:rPr>
+              <a:t>Share (2 min) — optional, one circle, by invitation; received with “Thank you.”</a:t>
+            </a:r>
+          </a:p>
+          <a:p>
+            <a:pPr marL="342900" indent="-342900">
+              <a:spcAft>
+                <a:spcPts val="750"/>
+              </a:spcAft>
+            </a:pPr>
+            <a:r>
+              <a:rPr sz="2000" b="1" i="0">
+                <a:solidFill>
+                  <a:srgbClr val="97BC62"/>
+                </a:solidFill>
+                <a:latin typeface="Calibri"/>
+              </a:rPr>
               <a:t>•  </a:t>
             </a:r>
             <a:r>
-              <a:rPr sz="2800" b="0" i="0">
+              <a:rPr sz="2000" b="0" i="0">
                 <a:solidFill>
                   <a:srgbClr val="222B22"/>
                 </a:solidFill>
                 <a:latin typeface="Calibri"/>
               </a:rPr>
-              <a:t>“The resolution is the Spirit’s work. The naming is yours. We do the naming. He does what only He can.”</a:t>
+              <a:t>If nothing comes, that is honest. Silence is not a verdict on you</a:t>
             </a:r>
           </a:p>
         </p:txBody>
@@ -5536,6 +5630,278 @@
                 </a:solidFill>
                 <a:latin typeface="Cambria"/>
               </a:rPr>
+              <a:t>Merge and Surface</a:t>
+            </a:r>
+          </a:p>
+        </p:txBody>
+      </p:sp>
+      <p:sp>
+        <p:nvSpPr>
+          <p:cNvPr id="4" name="TextBox 4"/>
+          <p:cNvSpPr txBox="1"/>
+          <p:nvPr/>
+        </p:nvSpPr>
+        <p:spPr>
+          <a:xfrm>
+            <a:off x="822960" y="1554480"/>
+            <a:ext cx="10515600" cy="4892040"/>
+          </a:xfrm>
+          <a:prstGeom prst="rect">
+            <a:avLst/>
+          </a:prstGeom>
+          <a:noFill/>
+        </p:spPr>
+        <p:txBody>
+          <a:bodyPr wrap="square" lIns="91440" tIns="91440" rIns="91440" bIns="91440"/>
+          <a:lstStyle/>
+          <a:p>
+            <a:pPr marL="274320" indent="-274320">
+              <a:spcAft>
+                <a:spcPts val="900"/>
+              </a:spcAft>
+            </a:pPr>
+            <a:r>
+              <a:rPr sz="2800" b="1" i="0">
+                <a:solidFill>
+                  <a:srgbClr val="97BC62"/>
+                </a:solidFill>
+                <a:latin typeface="Calibri"/>
+              </a:rPr>
+              <a:t>•  </a:t>
+            </a:r>
+            <a:r>
+              <a:rPr sz="2800" b="0" i="0">
+                <a:solidFill>
+                  <a:srgbClr val="222B22"/>
+                </a:solidFill>
+                <a:latin typeface="Calibri"/>
+              </a:rPr>
+              <a:t>What happened in your pair stays in your pair — no one will be asked to share a doubt or a scripture</a:t>
+            </a:r>
+          </a:p>
+          <a:p>
+            <a:pPr marL="274320" indent="-274320">
+              <a:spcAft>
+                <a:spcPts val="900"/>
+              </a:spcAft>
+            </a:pPr>
+            <a:r>
+              <a:rPr sz="2800" b="1" i="0">
+                <a:solidFill>
+                  <a:srgbClr val="97BC62"/>
+                </a:solidFill>
+                <a:latin typeface="Calibri"/>
+              </a:rPr>
+              <a:t>•  </a:t>
+            </a:r>
+            <a:r>
+              <a:rPr sz="2800" b="0" i="0">
+                <a:solidFill>
+                  <a:srgbClr val="222B22"/>
+                </a:solidFill>
+                <a:latin typeface="Calibri"/>
+              </a:rPr>
+              <a:t>“One word about what the practice was like. Not the doubt — the practice.”</a:t>
+            </a:r>
+          </a:p>
+          <a:p>
+            <a:pPr marL="685800" indent="-274320">
+              <a:spcAft>
+                <a:spcPts val="700"/>
+              </a:spcAft>
+            </a:pPr>
+            <a:r>
+              <a:rPr sz="2000" b="1" i="0">
+                <a:solidFill>
+                  <a:srgbClr val="97BC62"/>
+                </a:solidFill>
+                <a:latin typeface="Calibri"/>
+              </a:rPr>
+              <a:t>–  </a:t>
+            </a:r>
+            <a:r>
+              <a:rPr sz="2000" b="0" i="1">
+                <a:solidFill>
+                  <a:srgbClr val="222B22"/>
+                </a:solidFill>
+                <a:latin typeface="Calibri"/>
+              </a:rPr>
+              <a:t>“Surprising.” “Heavy.” “Quiet.” “Awkward.” “Honest.” “Lighter.” Pass anytime</a:t>
+            </a:r>
+          </a:p>
+          <a:p>
+            <a:pPr marL="274320" indent="-274320">
+              <a:spcAft>
+                <a:spcPts val="900"/>
+              </a:spcAft>
+            </a:pPr>
+            <a:r>
+              <a:rPr sz="2800" b="1" i="0">
+                <a:solidFill>
+                  <a:srgbClr val="97BC62"/>
+                </a:solidFill>
+                <a:latin typeface="Calibri"/>
+              </a:rPr>
+              <a:t>•  </a:t>
+            </a:r>
+            <a:r>
+              <a:rPr sz="2800" b="0" i="0">
+                <a:solidFill>
+                  <a:srgbClr val="222B22"/>
+                </a:solidFill>
+                <a:latin typeface="Calibri"/>
+              </a:rPr>
+              <a:t>This practice fits in five minutes alone, or twenty with a friend — a way of bringing your real questions to God for the rest of your life</a:t>
+            </a:r>
+          </a:p>
+          <a:p>
+            <a:pPr marL="274320" indent="-274320">
+              <a:spcAft>
+                <a:spcPts val="900"/>
+              </a:spcAft>
+            </a:pPr>
+            <a:r>
+              <a:rPr sz="2800" b="1" i="0">
+                <a:solidFill>
+                  <a:srgbClr val="97BC62"/>
+                </a:solidFill>
+                <a:latin typeface="Calibri"/>
+              </a:rPr>
+              <a:t>•  </a:t>
+            </a:r>
+            <a:r>
+              <a:rPr sz="2800" b="0" i="0">
+                <a:solidFill>
+                  <a:srgbClr val="222B22"/>
+                </a:solidFill>
+                <a:latin typeface="Calibri"/>
+              </a:rPr>
+              <a:t>“The resolution is the Spirit’s work. The naming is yours. We do the naming. He does what only He can.”</a:t>
+            </a:r>
+          </a:p>
+        </p:txBody>
+      </p:sp>
+      <p:sp>
+        <p:nvSpPr>
+          <p:cNvPr id="90" name="SlideNum"/>
+          <p:cNvSpPr txBox="1"/>
+          <p:nvPr/>
+        </p:nvSpPr>
+        <p:spPr>
+          <a:xfrm>
+            <a:off x="11384280" y="6446520"/>
+            <a:ext cx="640080" cy="292608"/>
+          </a:xfrm>
+          <a:prstGeom prst="rect">
+            <a:avLst/>
+          </a:prstGeom>
+          <a:noFill/>
+        </p:spPr>
+        <p:txBody>
+          <a:bodyPr wrap="none" lIns="0" tIns="0" rIns="45720" bIns="0" anchor="ctr"/>
+          <a:lstStyle/>
+          <a:p>
+            <a:pPr algn="r"/>
+            <a:r>
+              <a:t>169</a:t>
+            </a:r>
+            <a:endParaRPr sz="1000" b="1">
+              <a:solidFill>
+                <a:srgbClr val="7A8A6E"/>
+              </a:solidFill>
+              <a:latin typeface="Calibri"/>
+            </a:endParaRPr>
+          </a:p>
+        </p:txBody>
+      </p:sp>
+    </p:spTree>
+  </p:cSld>
+  <p:clrMapOvr>
+    <a:masterClrMapping/>
+  </p:clrMapOvr>
+</p:sld>
+</file>
+
+<file path=ppt/slides/slide13.xml><?xml version="1.0" encoding="utf-8"?>
+<p:sld xmlns:a="http://schemas.openxmlformats.org/drawingml/2006/main" xmlns:r="http://schemas.openxmlformats.org/officeDocument/2006/relationships" xmlns:p="http://schemas.openxmlformats.org/presentationml/2006/main">
+  <p:cSld>
+    <p:spTree>
+      <p:nvGrpSpPr>
+        <p:cNvPr id="1" name=""/>
+        <p:cNvGrpSpPr/>
+        <p:nvPr/>
+      </p:nvGrpSpPr>
+      <p:grpSpPr>
+        <a:xfrm>
+          <a:off x="0" y="0"/>
+          <a:ext cx="0" cy="0"/>
+          <a:chOff x="0" y="0"/>
+          <a:chExt cx="0" cy="0"/>
+        </a:xfrm>
+      </p:grpSpPr>
+      <p:sp>
+        <p:nvSpPr>
+          <p:cNvPr id="2" name="Rectangle 1"/>
+          <p:cNvSpPr/>
+          <p:nvPr/>
+        </p:nvSpPr>
+        <p:spPr>
+          <a:xfrm>
+            <a:off x="0" y="0"/>
+            <a:ext cx="12191695" cy="6858000"/>
+          </a:xfrm>
+          <a:prstGeom prst="rect">
+            <a:avLst/>
+          </a:prstGeom>
+          <a:solidFill>
+            <a:srgbClr val="FFFFFF"/>
+          </a:solidFill>
+          <a:ln>
+            <a:noFill/>
+          </a:ln>
+        </p:spPr>
+        <p:txBody>
+          <a:bodyPr/>
+          <a:lstStyle/>
+          <a:p>
+            <a:endParaRPr/>
+          </a:p>
+        </p:txBody>
+      </p:sp>
+      <p:sp>
+        <p:nvSpPr>
+          <p:cNvPr id="3" name="TextBox 2"/>
+          <p:cNvSpPr txBox="1"/>
+          <p:nvPr/>
+        </p:nvSpPr>
+        <p:spPr>
+          <a:xfrm>
+            <a:off x="822960" y="502920"/>
+            <a:ext cx="10515600" cy="822960"/>
+          </a:xfrm>
+          <a:prstGeom prst="rect">
+            <a:avLst/>
+          </a:prstGeom>
+          <a:noFill/>
+        </p:spPr>
+        <p:txBody>
+          <a:bodyPr wrap="square">
+            <a:spAutoFit/>
+          </a:bodyPr>
+          <a:lstStyle/>
+          <a:p>
+            <a:pPr algn="l">
+              <a:spcAft>
+                <a:spcPts val="600"/>
+              </a:spcAft>
+            </a:pPr>
+            <a:r>
+              <a:rPr sz="2800" b="1" i="0">
+                <a:solidFill>
+                  <a:srgbClr val="2C5F2D"/>
+                </a:solidFill>
+                <a:latin typeface="Cambria"/>
+              </a:rPr>
               <a:t>Homework — Two Weeks, Four Parts — the Doubts Inventory</a:t>
             </a:r>
           </a:p>
@@ -5582,57 +5948,7 @@
                 </a:solidFill>
                 <a:latin typeface="Calibri"/>
               </a:rPr>
-              <a:t>The Personal Doubts Inventory — twenty minutes with your journal, once this week</a:t>
-            </a:r>
-          </a:p>
-          <a:p>
-            <a:pPr marL="342900" indent="-342900">
-              <a:spcAft>
-                <a:spcPts val="750"/>
-              </a:spcAft>
-            </a:pPr>
-            <a:r>
-              <a:rPr sz="2000" b="1" i="0">
-                <a:solidFill>
-                  <a:srgbClr val="97BC62"/>
-                </a:solidFill>
-                <a:latin typeface="Calibri"/>
-              </a:rPr>
-              <a:t>1   </a:t>
-            </a:r>
-            <a:r>
-              <a:rPr sz="2000" b="0" i="0">
-                <a:solidFill>
-                  <a:srgbClr val="222B22"/>
-                </a:solidFill>
-                <a:latin typeface="Calibri"/>
-              </a:rPr>
-              <a:t>List 5–10 scriptures you say you believe; rate your honest trust, 1–5</a:t>
-            </a:r>
-          </a:p>
-          <a:p>
-            <a:pPr marL="342900" indent="-342900">
-              <a:spcAft>
-                <a:spcPts val="750"/>
-              </a:spcAft>
-            </a:pPr>
-            <a:r>
-              <a:rPr sz="2000" b="1" i="0">
-                <a:solidFill>
-                  <a:srgbClr val="97BC62"/>
-                </a:solidFill>
-                <a:latin typeface="Calibri"/>
-              </a:rPr>
-              <a:t>2   </a:t>
-            </a:r>
-            <a:r>
-              <a:rPr sz="2000" b="0" i="0">
-                <a:solidFill>
-                  <a:srgbClr val="222B22"/>
-                </a:solidFill>
-                <a:latin typeface="Calibri"/>
-              </a:rPr>
-              <a:t>For the two or three with the most hesitation — write the specific doubt, then sit with it</a:t>
+              <a:t>Week one: the Personal Doubts Inventory — twenty minutes with your journal, once</a:t>
             </a:r>
           </a:p>
           <a:p>
@@ -5648,7 +5964,7 @@
                 </a:solidFill>
                 <a:latin typeface="Calibri"/>
               </a:rPr>
-              <a:t>•  </a:t>
+              <a:t>1   </a:t>
             </a:r>
             <a:r>
               <a:rPr sz="2000" b="0" i="0">
@@ -5657,7 +5973,7 @@
                 </a:solidFill>
                 <a:latin typeface="Calibri"/>
               </a:rPr>
-              <a:t>No shame. Just data. Yours alone — never turned in, never seen by the team</a:t>
+              <a:t>List 5–10 scriptures you say you believe; rate your honest trust, 1–5</a:t>
             </a:r>
           </a:p>
           <a:p>
@@ -5673,7 +5989,7 @@
                 </a:solidFill>
                 <a:latin typeface="Calibri"/>
               </a:rPr>
-              <a:t>•  </a:t>
+              <a:t>2   </a:t>
             </a:r>
             <a:r>
               <a:rPr sz="2000" b="0" i="0">
@@ -5682,7 +5998,7 @@
                 </a:solidFill>
                 <a:latin typeface="Calibri"/>
               </a:rPr>
-              <a:t>The Quarterly Pulse goes home tonight — three questions, five minutes, honest. Back in the bin at The Return’s door in January</a:t>
+              <a:t>For the two or three with the most hesitation — write the specific doubt, then sit with it</a:t>
             </a:r>
           </a:p>
           <a:p>
@@ -5707,7 +6023,82 @@
                 </a:solidFill>
                 <a:latin typeface="Calibri"/>
               </a:rPr>
-              <a:t>Over the break: keep one practice alive — just one, your choice</a:t>
+              <a:t>Week two, two journal questions: Is there something I heard and did not obey? What is at risk for me to hear?</a:t>
+            </a:r>
+          </a:p>
+          <a:p>
+            <a:pPr marL="274320" indent="-274320">
+              <a:spcAft>
+                <a:spcPts val="750"/>
+              </a:spcAft>
+            </a:pPr>
+            <a:r>
+              <a:rPr sz="2000" b="1" i="0">
+                <a:solidFill>
+                  <a:srgbClr val="97BC62"/>
+                </a:solidFill>
+                <a:latin typeface="Calibri"/>
+              </a:rPr>
+              <a:t>•  </a:t>
+            </a:r>
+            <a:r>
+              <a:rPr sz="2000" b="0" i="0">
+                <a:solidFill>
+                  <a:srgbClr val="222B22"/>
+                </a:solidFill>
+                <a:latin typeface="Calibri"/>
+              </a:rPr>
+              <a:t>Not sure something was God? Test it with the How Did You Know? card — in company</a:t>
+            </a:r>
+          </a:p>
+          <a:p>
+            <a:pPr marL="274320" indent="-274320">
+              <a:spcAft>
+                <a:spcPts val="750"/>
+              </a:spcAft>
+            </a:pPr>
+            <a:r>
+              <a:rPr sz="2000" b="1" i="0">
+                <a:solidFill>
+                  <a:srgbClr val="97BC62"/>
+                </a:solidFill>
+                <a:latin typeface="Calibri"/>
+              </a:rPr>
+              <a:t>•  </a:t>
+            </a:r>
+            <a:r>
+              <a:rPr sz="2000" b="0" i="0">
+                <a:solidFill>
+                  <a:srgbClr val="222B22"/>
+                </a:solidFill>
+                <a:latin typeface="Calibri"/>
+              </a:rPr>
+              <a:t>No shame. Just data. Yours alone — never turned in, never seen by the team</a:t>
+            </a:r>
+          </a:p>
+          <a:p>
+            <a:pPr marL="274320" indent="-274320">
+              <a:spcAft>
+                <a:spcPts val="750"/>
+              </a:spcAft>
+            </a:pPr>
+            <a:r>
+              <a:rPr sz="2000" b="1" i="0">
+                <a:solidFill>
+                  <a:srgbClr val="97BC62"/>
+                </a:solidFill>
+                <a:latin typeface="Calibri"/>
+              </a:rPr>
+              <a:t>•  </a:t>
+            </a:r>
+            <a:r>
+              <a:rPr sz="2000" b="0" i="0">
+                <a:solidFill>
+                  <a:srgbClr val="222B22"/>
+                </a:solidFill>
+                <a:latin typeface="Calibri"/>
+              </a:rPr>
+              <a:t>The Quarterly Pulse goes home tonight — three questions, five minutes; bring it back next evening</a:t>
             </a:r>
           </a:p>
         </p:txBody>
@@ -5734,7 +6125,7 @@
           <a:p>
             <a:pPr algn="r"/>
             <a:r>
-              <a:t>169</a:t>
+              <a:t>170</a:t>
             </a:r>
             <a:endParaRPr sz="1000" b="1">
               <a:solidFill>
@@ -5789,7 +6180,7 @@
 </p:sld>
 </file>
 
-<file path=ppt/slides/slide13.xml><?xml version="1.0" encoding="utf-8"?>
+<file path=ppt/slides/slide14.xml><?xml version="1.0" encoding="utf-8"?>
 <p:sld xmlns:a="http://schemas.openxmlformats.org/drawingml/2006/main" xmlns:p="http://schemas.openxmlformats.org/presentationml/2006/main" xmlns:r="http://schemas.openxmlformats.org/officeDocument/2006/relationships">
   <p:cSld>
     <p:spTree>
@@ -5962,7 +6353,7 @@
           <a:p>
             <a:pPr algn="r"/>
             <a:r>
-              <a:t>170</a:t>
+              <a:t>171</a:t>
             </a:r>
             <a:endParaRPr sz="1000" b="1">
               <a:solidFill>
@@ -5981,7 +6372,7 @@
 </p:sld>
 </file>
 
-<file path=ppt/slides/slide14.xml><?xml version="1.0" encoding="utf-8"?>
+<file path=ppt/slides/slide15.xml><?xml version="1.0" encoding="utf-8"?>
 <p:sld xmlns:a="http://schemas.openxmlformats.org/drawingml/2006/main" xmlns:p="http://schemas.openxmlformats.org/presentationml/2006/main" xmlns:r="http://schemas.openxmlformats.org/officeDocument/2006/relationships">
   <p:cSld>
     <p:spTree>
@@ -6154,7 +6545,7 @@
           <a:p>
             <a:pPr algn="r"/>
             <a:r>
-              <a:t>171</a:t>
+              <a:t>172</a:t>
             </a:r>
             <a:endParaRPr sz="1000" b="1">
               <a:solidFill>
@@ -6173,7 +6564,7 @@
 </p:sld>
 </file>
 
-<file path=ppt/slides/slide15.xml><?xml version="1.0" encoding="utf-8"?>
+<file path=ppt/slides/slide16.xml><?xml version="1.0" encoding="utf-8"?>
 <p:sld xmlns:a="http://schemas.openxmlformats.org/drawingml/2006/main" xmlns:r="http://schemas.openxmlformats.org/officeDocument/2006/relationships" xmlns:p="http://schemas.openxmlformats.org/presentationml/2006/main">
   <p:cSld>
     <p:spTree>
@@ -6451,7 +6842,7 @@
           <a:p>
             <a:pPr algn="r"/>
             <a:r>
-              <a:t>172</a:t>
+              <a:t>173</a:t>
             </a:r>
             <a:endParaRPr sz="1000" b="1">
               <a:solidFill>
@@ -6506,7 +6897,7 @@
 </p:sld>
 </file>
 
-<file path=ppt/slides/slide16.xml><?xml version="1.0" encoding="utf-8"?>
+<file path=ppt/slides/slide17.xml><?xml version="1.0" encoding="utf-8"?>
 <p:sld xmlns:a="http://schemas.openxmlformats.org/drawingml/2006/main" xmlns:r="http://schemas.openxmlformats.org/officeDocument/2006/relationships" xmlns:p="http://schemas.openxmlformats.org/presentationml/2006/main">
   <p:cSld>
     <p:spTree>
@@ -6896,7 +7287,7 @@
           <a:p>
             <a:pPr algn="r"/>
             <a:r>
-              <a:t>173</a:t>
+              <a:t>174</a:t>
             </a:r>
             <a:endParaRPr sz="1000" b="1">
               <a:solidFill>
@@ -6915,7 +7306,7 @@
 </p:sld>
 </file>
 
-<file path=ppt/slides/slide17.xml><?xml version="1.0" encoding="utf-8"?>
+<file path=ppt/slides/slide18.xml><?xml version="1.0" encoding="utf-8"?>
 <p:sld xmlns:a="http://schemas.openxmlformats.org/drawingml/2006/main" xmlns:r="http://schemas.openxmlformats.org/officeDocument/2006/relationships" xmlns:p="http://schemas.openxmlformats.org/presentationml/2006/main">
   <p:cSld>
     <p:spTree>
@@ -7070,7 +7461,7 @@
           <a:p>
             <a:pPr algn="r"/>
             <a:r>
-              <a:t>174</a:t>
+              <a:t>175</a:t>
             </a:r>
             <a:endParaRPr sz="1000" b="1">
               <a:solidFill>
@@ -7473,7 +7864,7 @@
                 </a:solidFill>
                 <a:latin typeface="Calibri"/>
               </a:rPr>
-              <a:t> — at the year's midpoint. Each connection makes the next one real (Matt. 22:37–40).</a:t>
+              <a:t>. Each connection makes the next one real (Matt. 22:37–40).</a:t>
             </a:r>
           </a:p>
         </p:txBody>
@@ -7672,7 +8063,7 @@
               </a:spcAft>
             </a:pPr>
             <a:r>
-              <a:rPr sz="2800" b="1">
+              <a:rPr sz="2200" b="1">
                 <a:solidFill>
                   <a:srgbClr val="97BC62"/>
                 </a:solidFill>
@@ -7681,7 +8072,7 @@
               <a:t>1   </a:t>
             </a:r>
             <a:r>
-              <a:rPr sz="2800">
+              <a:rPr sz="2200">
                 <a:solidFill>
                   <a:srgbClr val="222B22"/>
                 </a:solidFill>
@@ -7697,7 +8088,7 @@
               </a:spcAft>
             </a:pPr>
             <a:r>
-              <a:rPr sz="2800" b="1">
+              <a:rPr sz="2200" b="1">
                 <a:solidFill>
                   <a:srgbClr val="97BC62"/>
                 </a:solidFill>
@@ -7706,13 +8097,13 @@
               <a:t>2   </a:t>
             </a:r>
             <a:r>
-              <a:rPr sz="2800">
+              <a:rPr sz="2200">
                 <a:solidFill>
                   <a:srgbClr val="222B22"/>
                 </a:solidFill>
                 <a:latin typeface="Calibri"/>
               </a:rPr>
-              <a:t>Week 9 check-in</a:t>
+              <a:t>Check-in — the garden, and what I’m not sure was God</a:t>
             </a:r>
           </a:p>
           <a:p>
@@ -7722,7 +8113,7 @@
               </a:spcAft>
             </a:pPr>
             <a:r>
-              <a:rPr sz="2800" b="1">
+              <a:rPr sz="2200" b="1">
                 <a:solidFill>
                   <a:srgbClr val="97BC62"/>
                 </a:solidFill>
@@ -7731,7 +8122,7 @@
               <a:t>3   </a:t>
             </a:r>
             <a:r>
-              <a:rPr sz="2800">
+              <a:rPr sz="2200">
                 <a:solidFill>
                   <a:srgbClr val="222B22"/>
                 </a:solidFill>
@@ -7747,7 +8138,7 @@
               </a:spcAft>
             </a:pPr>
             <a:r>
-              <a:rPr sz="2800" b="1">
+              <a:rPr sz="2200" b="1">
                 <a:solidFill>
                   <a:srgbClr val="97BC62"/>
                 </a:solidFill>
@@ -7756,7 +8147,7 @@
               <a:t>4   </a:t>
             </a:r>
             <a:r>
-              <a:rPr sz="2800">
+              <a:rPr sz="2200">
                 <a:solidFill>
                   <a:srgbClr val="222B22"/>
                 </a:solidFill>
@@ -7772,7 +8163,7 @@
               </a:spcAft>
             </a:pPr>
             <a:r>
-              <a:rPr sz="2800" b="1">
+              <a:rPr sz="2200" b="1">
                 <a:solidFill>
                   <a:srgbClr val="97BC62"/>
                 </a:solidFill>
@@ -7781,13 +8172,13 @@
               <a:t>5   </a:t>
             </a:r>
             <a:r>
-              <a:rPr sz="2800">
+              <a:rPr sz="2200">
                 <a:solidFill>
                   <a:srgbClr val="222B22"/>
                 </a:solidFill>
                 <a:latin typeface="Calibri"/>
               </a:rPr>
-              <a:t>Bridge to split</a:t>
+              <a:t>Bridge to pairs</a:t>
             </a:r>
           </a:p>
           <a:p>
@@ -7797,7 +8188,7 @@
               </a:spcAft>
             </a:pPr>
             <a:r>
-              <a:rPr sz="2800" b="1">
+              <a:rPr sz="2200" b="1">
                 <a:solidFill>
                   <a:srgbClr val="97BC62"/>
                 </a:solidFill>
@@ -7806,7 +8197,7 @@
               <a:t>6   </a:t>
             </a:r>
             <a:r>
-              <a:rPr sz="2800">
+              <a:rPr sz="2200">
                 <a:solidFill>
                   <a:srgbClr val="222B22"/>
                 </a:solidFill>
@@ -7822,7 +8213,7 @@
               </a:spcAft>
             </a:pPr>
             <a:r>
-              <a:rPr sz="2800" b="1">
+              <a:rPr sz="2200" b="1">
                 <a:solidFill>
                   <a:srgbClr val="97BC62"/>
                 </a:solidFill>
@@ -7831,13 +8222,13 @@
               <a:t>7   </a:t>
             </a:r>
             <a:r>
-              <a:rPr sz="2800">
+              <a:rPr sz="2200">
                 <a:solidFill>
                   <a:srgbClr val="222B22"/>
                 </a:solidFill>
                 <a:latin typeface="Calibri"/>
               </a:rPr>
-              <a:t>Merge and surface</a:t>
+              <a:t>The silent place — bringing in the time you heard</a:t>
             </a:r>
           </a:p>
           <a:p>
@@ -7847,7 +8238,7 @@
               </a:spcAft>
             </a:pPr>
             <a:r>
-              <a:rPr sz="2800" b="1">
+              <a:rPr sz="2200" b="1">
                 <a:solidFill>
                   <a:srgbClr val="97BC62"/>
                 </a:solidFill>
@@ -7856,13 +8247,13 @@
               <a:t>8   </a:t>
             </a:r>
             <a:r>
-              <a:rPr sz="2800">
+              <a:rPr sz="2200">
                 <a:solidFill>
                   <a:srgbClr val="222B22"/>
                 </a:solidFill>
                 <a:latin typeface="Calibri"/>
               </a:rPr>
-              <a:t>Homework commissioning — handout + check-in partners</a:t>
+              <a:t>Merge and surface</a:t>
             </a:r>
           </a:p>
           <a:p>
@@ -7872,7 +8263,7 @@
               </a:spcAft>
             </a:pPr>
             <a:r>
-              <a:rPr sz="2800" b="1">
+              <a:rPr sz="2200" b="1">
                 <a:solidFill>
                   <a:srgbClr val="97BC62"/>
                 </a:solidFill>
@@ -7881,13 +8272,13 @@
               <a:t>9   </a:t>
             </a:r>
             <a:r>
-              <a:rPr sz="2800">
+              <a:rPr sz="2200">
                 <a:solidFill>
                   <a:srgbClr val="222B22"/>
                 </a:solidFill>
                 <a:latin typeface="Calibri"/>
               </a:rPr>
-              <a:t>Leader Feedback Round</a:t>
+              <a:t>Homework — handout + check-in partners</a:t>
             </a:r>
           </a:p>
           <a:p>
@@ -7897,16 +8288,41 @@
               </a:spcAft>
             </a:pPr>
             <a:r>
-              <a:rPr sz="2800" b="1">
+              <a:rPr sz="2200" b="1">
                 <a:solidFill>
                   <a:srgbClr val="97BC62"/>
                 </a:solidFill>
                 <a:latin typeface="Calibri"/>
               </a:rPr>
-              <a:t>10   </a:t>
-            </a:r>
-            <a:r>
-              <a:rPr sz="2800">
+              <a:t>10  </a:t>
+            </a:r>
+            <a:r>
+              <a:rPr sz="2200">
+                <a:solidFill>
+                  <a:srgbClr val="222B22"/>
+                </a:solidFill>
+                <a:latin typeface="Calibri"/>
+              </a:rPr>
+              <a:t>Leader Feedback Round</a:t>
+            </a:r>
+          </a:p>
+          <a:p>
+            <a:pPr>
+              <a:spcAft>
+                <a:spcPts val="500"/>
+              </a:spcAft>
+            </a:pPr>
+            <a:r>
+              <a:rPr sz="2200" b="1">
+                <a:solidFill>
+                  <a:srgbClr val="97BC62"/>
+                </a:solidFill>
+                <a:latin typeface="Calibri"/>
+              </a:rPr>
+              <a:t>11  </a:t>
+            </a:r>
+            <a:r>
+              <a:rPr sz="2200">
                 <a:solidFill>
                   <a:srgbClr val="222B22"/>
                 </a:solidFill>
@@ -8421,7 +8837,7 @@
                 </a:solidFill>
                 <a:latin typeface="Cambria"/>
               </a:rPr>
-              <a:t>Week 9 Check-In — the Garden Returns</a:t>
+              <a:t>Check-In — the Garden, and What I’m Not Sure Was God</a:t>
             </a:r>
           </a:p>
         </p:txBody>
@@ -8452,7 +8868,7 @@
               </a:spcAft>
             </a:pPr>
             <a:r>
-              <a:rPr sz="2800" b="1" i="0">
+              <a:rPr sz="2600" b="1" i="0">
                 <a:solidFill>
                   <a:srgbClr val="97BC62"/>
                 </a:solidFill>
@@ -8461,13 +8877,13 @@
               <a:t>•  </a:t>
             </a:r>
             <a:r>
-              <a:rPr sz="2800" b="0" i="0">
+              <a:rPr sz="2600" b="0" i="0">
                 <a:solidFill>
                   <a:srgbClr val="222B22"/>
                 </a:solidFill>
                 <a:latin typeface="Calibri"/>
               </a:rPr>
-              <a:t>The practice was three returns to the garden</a:t>
+              <a:t>Three returns to the garden — one sentence: how did it go? Did you test what you noticed?</a:t>
             </a:r>
           </a:p>
           <a:p>
@@ -8477,7 +8893,7 @@
               </a:spcAft>
             </a:pPr>
             <a:r>
-              <a:rPr sz="2800" b="1" i="0">
+              <a:rPr sz="2600" b="1" i="0">
                 <a:solidFill>
                   <a:srgbClr val="97BC62"/>
                 </a:solidFill>
@@ -8486,13 +8902,13 @@
               <a:t>•  </a:t>
             </a:r>
             <a:r>
-              <a:rPr sz="2800" b="0" i="0">
+              <a:rPr sz="2600" b="0" i="0">
                 <a:solidFill>
                   <a:srgbClr val="222B22"/>
                 </a:solidFill>
                 <a:latin typeface="Calibri"/>
               </a:rPr>
-              <a:t>“Anyone want to say one sentence about how that went — the garden visits, or what surfaced, or that you didn’t get to it?”</a:t>
+              <a:t>Your preparation sentence: “One thing I’m not sure was God, or one question I’d bring tonight” — say it, or keep it for your pair</a:t>
             </a:r>
           </a:p>
           <a:p>
@@ -8502,7 +8918,7 @@
               </a:spcAft>
             </a:pPr>
             <a:r>
-              <a:rPr sz="2800" b="1" i="0">
+              <a:rPr sz="2600" b="1" i="0">
                 <a:solidFill>
                   <a:srgbClr val="97BC62"/>
                 </a:solidFill>
@@ -8511,7 +8927,7 @@
               <a:t>•  </a:t>
             </a:r>
             <a:r>
-              <a:rPr sz="2800" b="0" i="0">
+              <a:rPr sz="2600" b="0" i="0">
                 <a:solidFill>
                   <a:srgbClr val="222B22"/>
                 </a:solidFill>
@@ -8521,13 +8937,13 @@
             </a:r>
           </a:p>
           <a:p>
-            <a:pPr marL="685800" indent="-274320">
+            <a:pPr marL="274320" indent="-274320">
               <a:spcAft>
-                <a:spcPts val="700"/>
+                <a:spcPts val="900"/>
               </a:spcAft>
             </a:pPr>
             <a:r>
-              <a:rPr sz="2000" b="1" i="0">
+              <a:rPr sz="2600" b="1" i="0">
                 <a:solidFill>
                   <a:srgbClr val="97BC62"/>
                 </a:solidFill>
@@ -8536,13 +8952,13 @@
               <a:t>–  </a:t>
             </a:r>
             <a:r>
-              <a:rPr sz="2000" b="0" i="1">
+              <a:rPr sz="2600" b="0" i="0">
                 <a:solidFill>
                   <a:srgbClr val="222B22"/>
                 </a:solidFill>
                 <a:latin typeface="Calibri"/>
               </a:rPr>
-              <a:t>“Good. The garden is still there. You can return any time. We continue.”</a:t>
+              <a:t>“Good. The garden is still there. Tonight we bring the questions.”</a:t>
             </a:r>
           </a:p>
         </p:txBody>
@@ -9073,7 +9489,7 @@
               </a:spcAft>
             </a:pPr>
             <a:r>
-              <a:rPr sz="2200" b="1" i="0">
+              <a:rPr sz="1900" b="1" i="0">
                 <a:solidFill>
                   <a:srgbClr val="97BC62"/>
                 </a:solidFill>
@@ -9082,7 +9498,7 @@
               <a:t>1   </a:t>
             </a:r>
             <a:r>
-              <a:rPr sz="2200" b="0" i="0">
+              <a:rPr sz="1900" b="0" i="0">
                 <a:solidFill>
                   <a:srgbClr val="222B22"/>
                 </a:solidFill>
@@ -9098,7 +9514,7 @@
               </a:spcAft>
             </a:pPr>
             <a:r>
-              <a:rPr sz="2200" b="1" i="0">
+              <a:rPr sz="1900" b="1" i="0">
                 <a:solidFill>
                   <a:srgbClr val="97BC62"/>
                 </a:solidFill>
@@ -9107,7 +9523,7 @@
               <a:t>2   </a:t>
             </a:r>
             <a:r>
-              <a:rPr sz="2200" b="0" i="0">
+              <a:rPr sz="1900" b="0" i="0">
                 <a:solidFill>
                   <a:srgbClr val="222B22"/>
                 </a:solidFill>
@@ -9123,7 +9539,7 @@
               </a:spcAft>
             </a:pPr>
             <a:r>
-              <a:rPr sz="2200" b="1" i="0">
+              <a:rPr sz="1900" b="1" i="0">
                 <a:solidFill>
                   <a:srgbClr val="97BC62"/>
                 </a:solidFill>
@@ -9132,7 +9548,7 @@
               <a:t>3   </a:t>
             </a:r>
             <a:r>
-              <a:rPr sz="2200" b="0" i="0">
+              <a:rPr sz="1900" b="0" i="0">
                 <a:solidFill>
                   <a:srgbClr val="222B22"/>
                 </a:solidFill>
@@ -9148,7 +9564,7 @@
               </a:spcAft>
             </a:pPr>
             <a:r>
-              <a:rPr sz="2200" b="1" i="0">
+              <a:rPr sz="1900" b="1" i="0">
                 <a:solidFill>
                   <a:srgbClr val="97BC62"/>
                 </a:solidFill>
@@ -9157,7 +9573,7 @@
               <a:t>4   </a:t>
             </a:r>
             <a:r>
-              <a:rPr sz="2200" b="0" i="0">
+              <a:rPr sz="1900" b="0" i="0">
                 <a:solidFill>
                   <a:srgbClr val="222B22"/>
                 </a:solidFill>
@@ -9167,13 +9583,13 @@
             </a:r>
           </a:p>
           <a:p>
-            <a:pPr marL="274320" indent="-274320">
+            <a:pPr marL="342900" indent="-342900">
               <a:spcAft>
                 <a:spcPts val="900"/>
               </a:spcAft>
             </a:pPr>
             <a:r>
-              <a:rPr sz="2200" b="1" i="0">
+              <a:rPr sz="1900" b="1" i="0">
                 <a:solidFill>
                   <a:srgbClr val="97BC62"/>
                 </a:solidFill>
@@ -9182,7 +9598,32 @@
               <a:t>•  </a:t>
             </a:r>
             <a:r>
-              <a:rPr sz="2200" b="0" i="0">
+              <a:rPr sz="1900" b="0" i="0">
+                <a:solidFill>
+                  <a:srgbClr val="222B22"/>
+                </a:solidFill>
+                <a:latin typeface="Calibri"/>
+              </a:rPr>
+              <a:t>Two kinds of doubt: what God has said — these four steps; whether I heard him — the How Did You Know? checks</a:t>
+            </a:r>
+          </a:p>
+          <a:p>
+            <a:pPr marL="342900" indent="-342900">
+              <a:spcAft>
+                <a:spcPts val="900"/>
+              </a:spcAft>
+            </a:pPr>
+            <a:r>
+              <a:rPr sz="1900" b="1" i="0">
+                <a:solidFill>
+                  <a:srgbClr val="97BC62"/>
+                </a:solidFill>
+                <a:latin typeface="Calibri"/>
+              </a:rPr>
+              <a:t>•  </a:t>
+            </a:r>
+            <a:r>
+              <a:rPr sz="1900" b="0" i="0">
                 <a:solidFill>
                   <a:srgbClr val="222B22"/>
                 </a:solidFill>

</xml_diff>

<commit_message>
v2.49: Evening 8, the return and the Christmas send-off (John's word, 2026-10-28) - the return round opens the evening 7:06-7:18 (which practices chosen and why, what held, did you come back on your own, which you would keep, then "one thing I'm not sure was God"); pairs 7:31-7:53 give back the minutes; quiet tally at the debrief; take-home to The Return on one page (inventory, check-in, two journal questions, then the break chosen from The Practices So Far, two preparation sentences); Practices So Far card with Any Doubts? added; deck (no slides added) return slide, road, homework, sheets, close, "Quarter" becomes "movement"; leader notes rebuilt; run sheet new clock, Block column widened, three pages; Evening 8 page brought in line with the 13 October design (silent place); synced to OneDrive
Co-Authored-By: Claude Opus 5.5 <noreply@anthropic.com>
</commit_message>
<xml_diff>
--- a/_implementation-notes/evening-series/FotH Evening Session 11 Slides DRAFT v1.pptx
+++ b/_implementation-notes/evening-series/FotH Evening Session 11 Slides DRAFT v1.pptx
@@ -844,7 +844,12 @@
           </a:p>
           <a:p>
             <a:r>
-              <a:t>BEATS: 1. Evening 8 — the last evening of Connect with God. Tonight picks up the Garden evening's thread: what I'm not sure was God. 2. Today: Any Doubts? — bringing the small quiet doubts we never say aloud, honestly, to God, in front of one other person. 3. With the Garden, one of the two highest-confidence practices in this whole body of work — treat it with care. 4. Frame it early and repeat it: doubt is not disbelief; this is the gap between what we say and what we actually trust. 5. The shape (John's word, 13 October): the four steps in pairs, then the silent place from the Four Connects deck — remember where God seemed silent, bring in the time you heard, invite Jesus in.</a:t>
+              <a:t>BEATS: 1. Evening 8 — the last evening of Connect with God. Tonight is the first evening after four weeks apart (no evening over Thanksgiving): it opens with the return round, then picks up the Garden evening's thread: what I'm not sure was God. 2. Today: Any Doubts? — bringing the small quiet doubts we never say aloud, honestly, to God, in front of one other person. 3. With the Garden, one of the two highest-confidence practices in this whole body of work — treat it with care. 4. Frame it early and repeat it: doubt is not disbelief; this is the gap between what we say and what we actually trust. 5. The shape (John's word, 13 October): the four steps in pairs, then the silent place from the Four Connects deck — remember where God seemed silent, bring in the time you heard, invite Jesus in.</a:t>
+            </a:r>
+          </a:p>
+          <a:p>
+            <a:r>
+              <a:t>THE BREAKS (John's word, 28 October): the return round opens tonight; the Christmas send-off closes it. The Return opens January.</a:t>
             </a:r>
           </a:p>
         </p:txBody>
@@ -946,17 +951,27 @@
           <a:lstStyle/>
           <a:p>
             <a:r>
-              <a:t>E8 · 7:06–7:14 · LEAD: CONTAINER HOLDER</a:t>
-            </a:r>
-          </a:p>
-          <a:p>
-            <a:r>
-              <a:t>BEATS: 1. One sentence on the garden returns — how it went, what surfaced, whether anyone tested what they noticed with the How Did You Know? card. 2. The preparation sentence from the Garden take-home: 'One thing I'm not sure was God, or one question I'd bring tonight.' Say it aloud, or keep it for your pair — both are fine. 3. Two or three voluntary contributions; receive without commentary. Move on with: 'Good. The garden is still there. Tonight we bring the questions.'</a:t>
-            </a:r>
-          </a:p>
-          <a:p>
-            <a:r>
-              <a:t>CUES: Arranged parent opens — never cold-call a teen; pass-anytime holds.</a:t>
+              <a:t>E8 · 7:06–7:18 · LEAD: CONTAINER HOLDER</a:t>
+            </a:r>
+          </a:p>
+          <a:p>
+            <a:r>
+              <a:t>BEATS: 1. Rebuild the room slowly: it has been four weeks. 2. Around the circle, one at a time, the leader first, then a parent: which practices did you choose for weeks three and four, and why; what held; when it slipped, did you come back to it on your own, because you wanted to; which one would you keep. A sentence on the garden weeks if they wish. 3. The preparation sentence from the Garden take-home, 'One thing I'm not sure was God': say it aloud, or keep it for your pair. 4. Receive each with 'We hear that'; no comment. Move on with: 'Good. The garden is still there. Tonight we bring the questions.'</a:t>
+            </a:r>
+          </a:p>
+          <a:p>
+            <a:r>
+              <a:t>GUARD: Cut the shame spiral off early, from the front: slips are data, and nobody owes an explanation for the gap. Receive 'No, not yet' as warmly as 'Yes.' If the gap was hard at home, that is a conversation with an adult tonight or this week, not a circle one.</a:t>
+            </a:r>
+          </a:p>
+          <a:p>
+            <a:r>
+              <a:t>TALLY: at the debrief, a quiet count for each practice: how many chose it, and how many would keep it. No names. This is the read on which practices people really want to do (John's word, 28 October); The Return runs it again for the Christmas choices.</a:t>
+            </a:r>
+          </a:p>
+          <a:p>
+            <a:r>
+              <a:t>CUES: Arranged parent opens after the leader; never cold-call a teen; pass-anytime holds.</a:t>
             </a:r>
           </a:p>
         </p:txBody>
@@ -1002,7 +1017,7 @@
           <a:lstStyle/>
           <a:p>
             <a:r>
-              <a:t>E8 · 7:14–7:20 · LEAD: CONTENT PRESENTER</a:t>
+              <a:t>E8 · 7:18–7:23 · LEAD: CONTENT PRESENTER</a:t>
             </a:r>
           </a:p>
           <a:p>
@@ -1053,7 +1068,7 @@
           <a:lstStyle/>
           <a:p>
             <a:r>
-              <a:t>E8 · 7:20–7:28 · LEAD: CONTENT PRESENTER</a:t>
+              <a:t>E8 · 7:23–7:30 · LEAD: CONTENT PRESENTER</a:t>
             </a:r>
           </a:p>
           <a:p>
@@ -1114,7 +1129,7 @@
           <a:lstStyle/>
           <a:p>
             <a:r>
-              <a:t>E8 · 7:28–7:30 · LEAD: CONTENT PRESENTER · TRANSITION</a:t>
+              <a:t>E8 · 7:30–7:31 · LEAD: CONTENT PRESENTER · TRANSITION</a:t>
             </a:r>
           </a:p>
           <a:p>
@@ -1170,12 +1185,12 @@
           <a:lstStyle/>
           <a:p>
             <a:r>
-              <a:t>E8 · 7:30–7:56 · LEAD: CONTENT PRESENTER · PAIRS</a:t>
-            </a:r>
-          </a:p>
-          <a:p>
-            <a:r>
-              <a:t>BEATS: 1. Twenty-six minutes: one full cycle each direction, about 12 min per turn, parent's turn first. The silent place follows, so hold the clock. Companion calls switches at seven minutes; never interrupt a re-read. 2. The turn: partner reads; 'the doubt I am holding is ___'; gentle exaggerate; sit 10–20s; re-read; 'what I notice this time is ___'. 3. Interventions: apologetics — 'we're not arguing the doubt'; no doubt found — honest, run the partner's cycle; exaggeration won't come — don't push; distress — stop the exaggeration, re-read, sit with them.</a:t>
+              <a:t>E8 · 7:31–7:53 · LEAD: CONTENT PRESENTER · PAIRS</a:t>
+            </a:r>
+          </a:p>
+          <a:p>
+            <a:r>
+              <a:t>BEATS: 1. Twenty-two minutes: one full cycle each direction, about 11 min per turn, parent's turn first. The silent place follows, so hold the clock. Companion calls switches at seven minutes; never interrupt a re-read. 2. The turn: partner reads; 'the doubt I am holding is ___'; gentle exaggerate; sit 10–20s; re-read; 'what I notice this time is ___'. 3. Interventions: apologetics — 'we're not arguing the doubt'; no doubt found — honest, run the partner's cycle; exaggeration won't come — don't push; distress — stop the exaggeration, re-read, sit with them.</a:t>
             </a:r>
           </a:p>
           <a:p>
@@ -1226,7 +1241,7 @@
           <a:lstStyle/>
           <a:p>
             <a:r>
-              <a:t>E8 · 8:09–8:15 · LEAD: CONTAINER HOLDER</a:t>
+              <a:t>E8 · 8:06–8:12 · LEAD: CONTAINER HOLDER</a:t>
             </a:r>
           </a:p>
           <a:p>
@@ -1282,12 +1297,17 @@
           <a:lstStyle/>
           <a:p>
             <a:r>
-              <a:t>E8 · 8:15–8:21 · LEAD: CONTENT PRESENTER</a:t>
-            </a:r>
-          </a:p>
-          <a:p>
-            <a:r>
-              <a:t>BEATS: 1. Week one, the Personal Doubts Inventory (H11.2): twenty minutes once — list 5–10 scriptures you say you believe, rate your honest trust in each, and write one specific sentence on the two or three lowest. No shame, just data; nobody ever sees it. 2. Week two, two journal questions from the Four Connects deck: 'Is there something I heard and did not obey?' — obedience opens you to hear more — and 'What is at risk for me to hear?' 3. Anything you're not sure was God: the How Did You Know? card, tested in company. 4. Hand out the Quarterly Pulse (H11.4): three questions, five minutes at home, honest — bring it back next evening.</a:t>
+              <a:t>E8 · 8:12–8:21 · LEAD: CONTENT PRESENTER</a:t>
+            </a:r>
+          </a:p>
+          <a:p>
+            <a:r>
+              <a:t>BEATS: 1. Week one, the Personal Doubts Inventory (H11.2): twenty minutes once; list 5–10 scriptures you say you believe, rate your honest trust in each, write one specific sentence on the two or three lowest. No shame, just data; nobody ever sees it. 2. The check-in at the end of week one. 3. Week two, two journal questions from the Four Connects deck: 'Is there something I heard and did not obey?' and 'What is at risk for me to hear?' 4. The Christmas break: after the two weeks, each week one practice from The Practices So Far card, the one you would really like to do, written down with why. Read the list once, aloud; never steer. 5. The returning rule; name who to reach over the break. 6. Hand out the Quarterly Pulse (H11.4): three questions, five minutes at home; bring it to The Return.</a:t>
+            </a:r>
+          </a:p>
+          <a:p>
+            <a:r>
+              <a:t>GUARD: Name the break plainly: how long it is, and that The Return opens by asking which practices were chosen and how it went. The choices are made at home, freely.</a:t>
             </a:r>
           </a:p>
           <a:p>
@@ -1394,7 +1414,7 @@
           </a:p>
           <a:p>
             <a:r>
-              <a:t>BEATS: 1. What was named in your pair is yours — some doubts quietly resolve, some deepen before they release; both are normal. If anything is heavier than tonight could hold, reach out. 2. Announce the next evening and its date, as the team has set it; Evening 9 turns toward Mission. 3. Aaronic blessing.</a:t>
+              <a:t>BEATS: 1. What was named in your pair is yours — some doubts quietly resolve, some deepen before they release; both are normal. If anything is heavier than tonight could hold, reach out. 2. Name the Christmas break plainly and who to reach over it; Evening 9, The Return, opens January and asks which practices you chose. Merry Christmas to every house. 3. Aaronic blessing.</a:t>
             </a:r>
           </a:p>
           <a:p>
@@ -1445,7 +1465,7 @@
           <a:lstStyle/>
           <a:p>
             <a:r>
-              <a:t>E8 · 7:56–8:09 · LEAD: CONTENT PRESENTER</a:t>
+              <a:t>E8 · 7:53–8:06 · LEAD: CONTENT PRESENTER</a:t>
             </a:r>
           </a:p>
           <a:p>
@@ -1511,7 +1531,7 @@
           <a:lstStyle/>
           <a:p>
             <a:r>
-              <a:t>QUARTER 3 · pre-session · DIVIDER</a:t>
+              <a:t>MOVEMENT 3 · pre-session · DIVIDER</a:t>
             </a:r>
           </a:p>
           <a:p>
@@ -1648,7 +1668,7 @@
           </a:p>
           <a:p>
             <a:r>
-              <a:t>2. The standing rhythm first: the morning question, the evening journal line — one box per day on the week-grids.</a:t>
+              <a:t>2. The standing rhythm first: the morning question, the evening journal line — one box per day, on one grid for the weeks to The Return.</a:t>
             </a:r>
           </a:p>
           <a:p>
@@ -1658,7 +1678,7 @@
           </a:p>
           <a:p>
             <a:r>
-              <a:t>CUES: The four parts are the next slide.</a:t>
+              <a:t>CUES: The five parts are the next slide.</a:t>
             </a:r>
           </a:p>
         </p:txBody>
@@ -1714,12 +1734,17 @@
           </a:p>
           <a:p>
             <a:r>
-              <a:t>1. The four parts, in order: the homework practice, week one; the end-of-week-one check-in; the homework practice, week two; one sentence of preparation.</a:t>
-            </a:r>
-          </a:p>
-          <a:p>
-            <a:r>
-              <a:t>2. Check-in partners are named aloud before leaving this slide — the sheet has the line to write the name.</a:t>
+              <a:t>1. The five parts, in order: week one, the doubts inventory; the end-of-week-one check-in; week two, the two journal questions; the rest of the break, your choice from The Practices So Far; two sentences of preparation for The Return.</a:t>
+            </a:r>
+          </a:p>
+          <a:p>
+            <a:r>
+              <a:t>2. Check-in partners are named aloud before leaving this slide; the sheet has the line to write the name.</a:t>
+            </a:r>
+          </a:p>
+          <a:p>
+            <a:r>
+              <a:t>3. The Practices So Far card goes with the sheet, with Any Doubts? now on it.</a:t>
             </a:r>
           </a:p>
           <a:p>
@@ -5900,7 +5925,7 @@
                 </a:solidFill>
                 <a:latin typeface="Cambria"/>
               </a:rPr>
-              <a:t>Homework — Two Weeks, Four Parts — the Doubts Inventory</a:t>
+              <a:t>Homework — Two Weeks, Then the Christmas Break</a:t>
             </a:r>
           </a:p>
         </p:txBody>
@@ -5946,7 +5971,7 @@
                 </a:solidFill>
                 <a:latin typeface="Calibri"/>
               </a:rPr>
-              <a:t>Week one: the Personal Doubts Inventory — twenty minutes with your journal, once</a:t>
+              <a:t>Week one: the Personal Doubts Inventory — twenty minutes, once; no shame, just data, never turned in</a:t>
             </a:r>
           </a:p>
           <a:p>
@@ -5962,7 +5987,7 @@
                 </a:solidFill>
                 <a:latin typeface="Calibri"/>
               </a:rPr>
-              <a:t>1   </a:t>
+              <a:t>•  </a:t>
             </a:r>
             <a:r>
               <a:rPr sz="2000" b="0" i="0">
@@ -5971,7 +5996,7 @@
                 </a:solidFill>
                 <a:latin typeface="Calibri"/>
               </a:rPr>
-              <a:t>List 5–10 scriptures you say you believe; rate your honest trust, 1–5</a:t>
+              <a:t>End of week one: the check-in with your partner</a:t>
             </a:r>
           </a:p>
           <a:p>
@@ -5987,7 +6012,7 @@
                 </a:solidFill>
                 <a:latin typeface="Calibri"/>
               </a:rPr>
-              <a:t>2   </a:t>
+              <a:t>•  </a:t>
             </a:r>
             <a:r>
               <a:rPr sz="2000" b="0" i="0">
@@ -5996,7 +6021,7 @@
                 </a:solidFill>
                 <a:latin typeface="Calibri"/>
               </a:rPr>
-              <a:t>For the two or three with the most hesitation — write the specific doubt, then sit with it</a:t>
+              <a:t>Week two, two journal questions: Is there something I heard and did not obey? What is at risk for me to hear?</a:t>
             </a:r>
           </a:p>
           <a:p>
@@ -6021,7 +6046,7 @@
                 </a:solidFill>
                 <a:latin typeface="Calibri"/>
               </a:rPr>
-              <a:t>Week two, two journal questions: Is there something I heard and did not obey? What is at risk for me to hear?</a:t>
+              <a:t>Then each week of the break: one practice from The Practices So Far — Any Doubts? is on it now — written down, with why</a:t>
             </a:r>
           </a:p>
           <a:p>
@@ -6046,7 +6071,7 @@
                 </a:solidFill>
                 <a:latin typeface="Calibri"/>
               </a:rPr>
-              <a:t>Not sure something was God? Test it with the How Did You Know? card — in company</a:t>
+              <a:t>If it slips: begin again the next day. No streaks. You know who to reach</a:t>
             </a:r>
           </a:p>
           <a:p>
@@ -6071,7 +6096,7 @@
                 </a:solidFill>
                 <a:latin typeface="Calibri"/>
               </a:rPr>
-              <a:t>No shame. Just data. Yours alone — never turned in, never seen by the team</a:t>
+              <a:t>The Return in January opens with: which did you choose? Did you come back on your own? Which would you keep?</a:t>
             </a:r>
           </a:p>
           <a:p>
@@ -6096,7 +6121,7 @@
                 </a:solidFill>
                 <a:latin typeface="Calibri"/>
               </a:rPr>
-              <a:t>The Quarterly Pulse goes home tonight — three questions, five minutes; bring it back next evening</a:t>
+              <a:t>The Quarterly Pulse goes home tonight — three questions, five minutes; bring it to The Return</a:t>
             </a:r>
           </a:p>
         </p:txBody>
@@ -6266,35 +6291,6 @@
           </a:p>
         </p:txBody>
       </p:sp>
-      <p:pic>
-        <p:nvPicPr>
-          <p:cNvPr id="4" name="Picture 3" descr="s11_part1.png"/>
-          <p:cNvPicPr>
-            <a:picLocks noChangeAspect="1"/>
-          </p:cNvPicPr>
-          <p:nvPr/>
-        </p:nvPicPr>
-        <p:blipFill>
-          <a:blip r:embed="rId2"/>
-          <a:stretch>
-            <a:fillRect/>
-          </a:stretch>
-        </p:blipFill>
-        <p:spPr>
-          <a:xfrm>
-            <a:off x="1798167" y="1463040"/>
-            <a:ext cx="8595360" cy="4039819"/>
-          </a:xfrm>
-          <a:prstGeom prst="rect">
-            <a:avLst/>
-          </a:prstGeom>
-          <a:ln w="12700">
-            <a:solidFill>
-              <a:srgbClr val="C8C8C8"/>
-            </a:solidFill>
-          </a:ln>
-        </p:spPr>
-      </p:pic>
       <p:sp>
         <p:nvSpPr>
           <p:cNvPr id="5" name="TextBox 4"/>
@@ -6362,6 +6358,30 @@
           </a:p>
         </p:txBody>
       </p:sp>
+      <p:pic>
+        <p:nvPicPr>
+          <p:cNvPr id="91" name="Picture 90" descr="e8new_s14.png"/>
+          <p:cNvPicPr>
+            <a:picLocks noChangeAspect="1"/>
+          </p:cNvPicPr>
+          <p:nvPr/>
+        </p:nvPicPr>
+        <p:blipFill>
+          <a:blip r:embed="rId4"/>
+          <a:stretch>
+            <a:fillRect/>
+          </a:stretch>
+        </p:blipFill>
+        <p:spPr>
+          <a:xfrm>
+            <a:off x="1798167" y="1463040"/>
+            <a:ext cx="8595360" cy="2957147"/>
+          </a:xfrm>
+          <a:prstGeom prst="rect">
+            <a:avLst/>
+          </a:prstGeom>
+        </p:spPr>
+      </p:pic>
     </p:spTree>
   </p:cSld>
   <p:clrMapOvr>
@@ -6453,40 +6473,11 @@
                 </a:solidFill>
                 <a:latin typeface="Cambria"/>
               </a:rPr>
-              <a:t>The Take-Home Sheet — the Four Parts</a:t>
-            </a:r>
-          </a:p>
-        </p:txBody>
-      </p:sp>
-      <p:pic>
-        <p:nvPicPr>
-          <p:cNvPr id="4" name="Picture 3" descr="s11_part2.png"/>
-          <p:cNvPicPr>
-            <a:picLocks noChangeAspect="1"/>
-          </p:cNvPicPr>
-          <p:nvPr/>
-        </p:nvPicPr>
-        <p:blipFill>
-          <a:blip r:embed="rId2"/>
-          <a:stretch>
-            <a:fillRect/>
-          </a:stretch>
-        </p:blipFill>
-        <p:spPr>
-          <a:xfrm>
-            <a:off x="2433167" y="1463040"/>
-            <a:ext cx="7325360" cy="4709160"/>
-          </a:xfrm>
-          <a:prstGeom prst="rect">
-            <a:avLst/>
-          </a:prstGeom>
-          <a:ln w="12700">
-            <a:solidFill>
-              <a:srgbClr val="C8C8C8"/>
-            </a:solidFill>
-          </a:ln>
-        </p:spPr>
-      </p:pic>
+              <a:t>The Take-Home Sheet — the Five Parts</a:t>
+            </a:r>
+          </a:p>
+        </p:txBody>
+      </p:sp>
       <p:sp>
         <p:nvSpPr>
           <p:cNvPr id="5" name="TextBox 4"/>
@@ -6516,7 +6507,7 @@
                 </a:solidFill>
                 <a:latin typeface="Calibri"/>
               </a:rPr>
-              <a:t>One practice at a time — and a partner expecting you at the end of week one.</a:t>
+              <a:t>Two weeks as always, then the break you choose — and a partner expecting you at the end of week one.</a:t>
             </a:r>
           </a:p>
         </p:txBody>
@@ -6554,6 +6545,30 @@
           </a:p>
         </p:txBody>
       </p:sp>
+      <p:pic>
+        <p:nvPicPr>
+          <p:cNvPr id="91" name="Picture 90" descr="e8new_s15.png"/>
+          <p:cNvPicPr>
+            <a:picLocks noChangeAspect="1"/>
+          </p:cNvPicPr>
+          <p:nvPr/>
+        </p:nvPicPr>
+        <p:blipFill>
+          <a:blip r:embed="rId4"/>
+          <a:stretch>
+            <a:fillRect/>
+          </a:stretch>
+        </p:blipFill>
+        <p:spPr>
+          <a:xfrm>
+            <a:off x="3485441" y="1463040"/>
+            <a:ext cx="5221118" cy="4800000"/>
+          </a:xfrm>
+          <a:prstGeom prst="rect">
+            <a:avLst/>
+          </a:prstGeom>
+        </p:spPr>
+      </p:pic>
     </p:spTree>
   </p:cSld>
   <p:clrMapOvr>
@@ -7400,7 +7415,7 @@
                 </a:solidFill>
                 <a:latin typeface="Calibri"/>
               </a:rPr>
-              <a:t>Quarter 3</a:t>
+              <a:t>The Third Movement</a:t>
             </a:r>
           </a:p>
           <a:p>
@@ -7681,7 +7696,7 @@
                 </a:solidFill>
                 <a:latin typeface="Calibri"/>
               </a:rPr>
-              <a:t>Quarter 2: Connect with God</a:t>
+              <a:t>The second movement: Connect with God</a:t>
             </a:r>
           </a:p>
         </p:txBody>
@@ -8101,7 +8116,7 @@
                 </a:solidFill>
                 <a:latin typeface="Calibri"/>
               </a:rPr>
-              <a:t>Check-in — the garden, and what I’m not sure was God</a:t>
+              <a:t>The return — four weeks, and what I’m not sure was God</a:t>
             </a:r>
           </a:p>
           <a:p>
@@ -8276,7 +8291,7 @@
                 </a:solidFill>
                 <a:latin typeface="Calibri"/>
               </a:rPr>
-              <a:t>Homework — handout + check-in partners</a:t>
+              <a:t>Homework and the Christmas break</a:t>
             </a:r>
           </a:p>
           <a:p>
@@ -8835,7 +8850,7 @@
                 </a:solidFill>
                 <a:latin typeface="Cambria"/>
               </a:rPr>
-              <a:t>Check-In — the Garden, and What I’m Not Sure Was God</a:t>
+              <a:t>The Return — Four Weeks, and What I’m Not Sure Was God</a:t>
             </a:r>
           </a:p>
         </p:txBody>
@@ -8881,7 +8896,7 @@
                 </a:solidFill>
                 <a:latin typeface="Calibri"/>
               </a:rPr>
-              <a:t>Three returns to the garden — one sentence: how did it go? Did you test what you noticed?</a:t>
+              <a:t>Which practices did you choose for weeks three and four — and why?</a:t>
             </a:r>
           </a:p>
           <a:p>
@@ -8906,7 +8921,7 @@
                 </a:solidFill>
                 <a:latin typeface="Calibri"/>
               </a:rPr>
-              <a:t>Your preparation sentence: “One thing I’m not sure was God, or one question I’d bring tonight” — say it, or keep it for your pair</a:t>
+              <a:t>What held? When it slipped, did you come back on your own?</a:t>
             </a:r>
           </a:p>
           <a:p>
@@ -8931,7 +8946,7 @@
                 </a:solidFill>
                 <a:latin typeface="Calibri"/>
               </a:rPr>
-              <a:t>One sentence each, voluntary — received without commentary</a:t>
+              <a:t>Which one would you keep?</a:t>
             </a:r>
           </a:p>
           <a:p>
@@ -8947,6 +8962,31 @@
                 </a:solidFill>
                 <a:latin typeface="Calibri"/>
               </a:rPr>
+              <a:t>•  </a:t>
+            </a:r>
+            <a:r>
+              <a:rPr sz="2600" b="0" i="0">
+                <a:solidFill>
+                  <a:srgbClr val="222B22"/>
+                </a:solidFill>
+                <a:latin typeface="Calibri"/>
+              </a:rPr>
+              <a:t>“One thing I’m not sure was God” — say it, or keep it for your pair</a:t>
+            </a:r>
+          </a:p>
+          <a:p>
+            <a:pPr marL="274320" indent="-274320">
+              <a:spcAft>
+                <a:spcPts val="900"/>
+              </a:spcAft>
+            </a:pPr>
+            <a:r>
+              <a:rPr sz="2600" b="1" i="0">
+                <a:solidFill>
+                  <a:srgbClr val="97BC62"/>
+                </a:solidFill>
+                <a:latin typeface="Calibri"/>
+              </a:rPr>
               <a:t>–  </a:t>
             </a:r>
             <a:r>
@@ -8956,7 +8996,7 @@
                 </a:solidFill>
                 <a:latin typeface="Calibri"/>
               </a:rPr>
-              <a:t>“Good. The garden is still there. Tonight we bring the questions.”</a:t>
+              <a:t>“We hear that.” No comment; slips are data</a:t>
             </a:r>
           </a:p>
         </p:txBody>

</xml_diff>

<commit_message>
v2.50: the Pulse dropped from the evening form (John's word, 2026-10-28) - gone from Evening 8 (homework slide and notes, run sheet, take-home and its slide image, page) and from Evening 9's deck notes (the return bin); leader notes rebuilt; the handbook's "quarterly look" becomes the return round at each long break with the quiet tally; Evenings 12 and 13 (Pulse 3) to rework when prepared; synced to OneDrive
Co-Authored-By: Claude Opus 5.5 <noreply@anthropic.com>
</commit_message>
<xml_diff>
--- a/_implementation-notes/evening-series/FotH Evening Session 11 Slides DRAFT v1.pptx
+++ b/_implementation-notes/evening-series/FotH Evening Session 11 Slides DRAFT v1.pptx
@@ -1302,7 +1302,7 @@
           </a:p>
           <a:p>
             <a:r>
-              <a:t>BEATS: 1. Week one, the Personal Doubts Inventory (H11.2): twenty minutes once; list 5–10 scriptures you say you believe, rate your honest trust in each, write one specific sentence on the two or three lowest. No shame, just data; nobody ever sees it. 2. The check-in at the end of week one. 3. Week two, two journal questions from the Four Connects deck: 'Is there something I heard and did not obey?' and 'What is at risk for me to hear?' 4. The Christmas break: after the two weeks, each week one practice from The Practices So Far card, the one you would really like to do, written down with why. Read the list once, aloud; never steer. 5. The returning rule; name who to reach over the break. 6. Hand out the Quarterly Pulse (H11.4): three questions, five minutes at home; bring it to The Return.</a:t>
+              <a:t>BEATS: 1. Week one, the Personal Doubts Inventory (H11.2): twenty minutes once; list 5–10 scriptures you say you believe, rate your honest trust in each, write one specific sentence on the two or three lowest. No shame, just data; nobody ever sees it. 2. The check-in at the end of week one. 3. Week two, two journal questions from the Four Connects deck: 'Is there something I heard and did not obey?' and 'What is at risk for me to hear?' 4. The Christmas break: after the two weeks, each week one practice from The Practices So Far card, the one you would really like to do, written down with why. Read the list once, aloud; never steer. 5. The returning rule; name who to reach over the break.</a:t>
             </a:r>
           </a:p>
           <a:p>
@@ -6099,31 +6099,6 @@
               <a:t>The Return in January opens with: which did you choose? Did you come back on your own? Which would you keep?</a:t>
             </a:r>
           </a:p>
-          <a:p>
-            <a:pPr marL="274320" indent="-274320">
-              <a:spcAft>
-                <a:spcPts val="750"/>
-              </a:spcAft>
-            </a:pPr>
-            <a:r>
-              <a:rPr sz="2000" b="1" i="0">
-                <a:solidFill>
-                  <a:srgbClr val="97BC62"/>
-                </a:solidFill>
-                <a:latin typeface="Calibri"/>
-              </a:rPr>
-              <a:t>•  </a:t>
-            </a:r>
-            <a:r>
-              <a:rPr sz="2000" b="0" i="0">
-                <a:solidFill>
-                  <a:srgbClr val="222B22"/>
-                </a:solidFill>
-                <a:latin typeface="Calibri"/>
-              </a:rPr>
-              <a:t>The Quarterly Pulse goes home tonight — three questions, five minutes; bring it to The Return</a:t>
-            </a:r>
-          </a:p>
         </p:txBody>
       </p:sp>
       <p:sp>
@@ -6547,22 +6522,22 @@
       </p:sp>
       <p:pic>
         <p:nvPicPr>
-          <p:cNvPr id="91" name="Picture 90" descr="e8new_s15.png"/>
+          <p:cNvPr id="91" name="Picture 90" descr="e8new_s15b.png"/>
           <p:cNvPicPr>
             <a:picLocks noChangeAspect="1"/>
           </p:cNvPicPr>
           <p:nvPr/>
         </p:nvPicPr>
         <p:blipFill>
-          <a:blip r:embed="rId4"/>
+          <a:blip r:embed="rId5"/>
           <a:stretch>
             <a:fillRect/>
           </a:stretch>
         </p:blipFill>
         <p:spPr>
           <a:xfrm>
-            <a:off x="3485441" y="1463040"/>
-            <a:ext cx="5221118" cy="4800000"/>
+            <a:off x="3399609" y="1463040"/>
+            <a:ext cx="5392782" cy="4800000"/>
           </a:xfrm>
           <a:prstGeom prst="rect">
             <a:avLst/>

</xml_diff>